<commit_message>
RT edge tier: final docs, README section and presentation (conditional conclusion, council history)
Co-Authored-By: Claude Fable 5.1 <noreply@anthropic.com>
Claude-Session: https://claude.ai/code/session_01BQ7efTVkjp2fGYyjphSZC9
</commit_message>
<xml_diff>
--- a/out/presentation/qd_edge_sps.pptx
+++ b/out/presentation/qd_edge_sps.pptx
@@ -590,7 +590,7 @@
           <a:lstStyle/>
           <a:p>
             <a:r>
-              <a:t>Electrical driving replaces the pump laser used by almost every other single-photon quantum-dot demonstration. fsim_core.transport.hkust_preset() builds the actual p-i-n stack used here: Al0.40Ga0.60As p- and n-claddings around a 148 nm intrinsic region, with the GaAs0.60P0.40 active layer (8 nm) at its centre, following Gu et al.'s (Optics Express 33, 23732, 2025) own electrically pumped device. Forward bias tilts the bands so electrons flow in from the n-side and holes from the p-side and both are captured by the dot in the middle. At the single-dot-scale drive current this design uses (I = 1.0 nA), fsim_core.transport's own I-V solver puts the junction voltage at V_j ≈ 1.28 V at 300 K.</a:t>
+              <a:t>Electrical driving replaces the pump laser used by almost every other single-photon quantum-dot demonstration. fsim_core.transport.hkust_preset() builds the actual p-i-n stack used here: Al0.40Ga0.60As p- and n-claddings around a 148 nm intrinsic region, with the GaAs0.60P0.40 active layer (8 nm) at its centre, following Gu et al.'s (Optics Express 33, 23732, 2025) own electrically pumped device. Forward bias tilts the bands so electrons flow in from the n-side and holes from the p-side and both are captured by the dot in the middle. At the single-dot-scale drive current this design uses (I = 11.3 nA), fsim_core.transport's own I-V solver puts the junction voltage at V_j ≈ 1.50 V at 300 K.</a:t>
             </a:r>
           </a:p>
         </p:txBody>
@@ -730,7 +730,7 @@
           <a:lstStyle/>
           <a:p>
             <a:r>
-              <a:t>fsim_core.waveguide.py solves the actual guided optical mode of the ridge stack (an (Al,Ga)InP core around the GaAsP well, on a GaAs substrate) with a scalar effective-index model (Lecamp, Lalanne &amp; Hugonin, Phys. Rev. Lett. 99, 023902 (2007)). For this design's stack at 668 nm the solved mode has n_eff = 3.47 and a beta factor (fraction of the dot's spontaneous emission that couples into the guided mode) of 1.83%, sweeping to 1.9% across the acceptance-sweep grid; an uncoated facet then transmits 70% of the guided light out of the chip (Fresnel reflection at the semiconductor-air interface). Per Lemma 1 of docs/rt_edge_contract.md, none of this changes the intrinsic multiphoton probability -- it only sets how much of the light that is emitted is actually collected.</a:t>
+              <a:t>fsim_core.waveguide.py solves the actual guided optical mode of the ridge stack (an (Al,Ga)InP core around the GaAsP well, on a GaAs substrate) with a scalar effective-index model (Lecamp, Lalanne &amp; Hugonin, Phys. Rev. Lett. 99, 023902 (2007)). For this design's stack at 668 nm the solved mode has n_eff = 3.18 and a beta factor (fraction of the dot's spontaneous emission that couples into the guided mode) of 2.87%, sweeping to 2.9% across the acceptance-sweep grid; an uncoated facet then transmits 73% of the guided light out of the chip (Fresnel reflection at the semiconductor-air interface). Per Lemma 1 of docs/rt_edge_contract.md, none of this changes the intrinsic multiphoton probability -- it only sets how much of the light that is emitted is actually collected.</a:t>
             </a:r>
           </a:p>
         </p:txBody>
@@ -800,7 +800,7 @@
           <a:lstStyle/>
           <a:p>
             <a:r>
-              <a:t>g2(0) is the only equation this deck states explicitly, and even it is explained rather than derived: it is the probability of detecting two photons at (almost) the same instant, normalized so that a classical, many-photon source gives 1 and a perfect single-photon emitter gives 0. The dashed curve on this slide is the published 300 K ceiling (no electrically or optically driven III-V dot has ever demonstrated g2(0) &lt; 0.5 at 300 K, docs/rt_edge_contract.md); the solid curve is this design's own best pulsed-drive corner from the acceptance sweep, g2 = 0.3648 -- better than the published ceiling, but only at the extreme corner of the swept range (narrowest linewidth, widest X-XX splitting) and only under pulsed, not continuous, drive.</a:t>
+              <a:t>g2(0) is the only equation this deck states explicitly, and even it is explained rather than derived: it is the probability of detecting two photons at (almost) the same instant, normalized so that a classical, many-photon source gives 1 and a perfect single-photon emitter gives 0. The dashed curve on this slide is the published 300 K ceiling (no electrically or optically driven III-V dot has ever demonstrated g2(0) &lt; 0.5 at 300 K, docs/rt_edge_contract.md); the solid curve is this design's own best pulsed-drive corner from the acceptance sweep, g2 = 0.4305 -- better than the published ceiling, but only at the extreme corner of the swept range (narrowest linewidth, widest X-XX splitting) and only under pulsed, not continuous, drive.</a:t>
             </a:r>
           </a:p>
         </p:txBody>
@@ -870,12 +870,12 @@
           <a:lstStyle/>
           <a:p>
             <a:r>
-              <a:t>VERDICT: FAIL g2_min=0.3648 g2_median=0.773 median_pass=false coverage=0 eligible=54/54 evidence=incomplete conditional=false</a:t>
-            </a:r>
-          </a:p>
-          <a:p>
-            <a:r>
-              <a:t>The sweep was generated by scripts/run_rt_edge.py (2026-09-05T20:24:08.189904+00:00) over the full contract-declared grid (docs/rt_edge_contract.md): dot.delta_xx in [4.0, 7.0] meV, dot.gamma300 in [6.0, 20.0] meV, and the detector response (IRF) in [50, 200] ps, evaluated for both the primary (GaAsP-well) and fallback (GaInP-well) design cards, each under pulsed and continuous-wave drive. The envelope figure shown here (out/rt_edge/envelope.png) is the sweep's own output, not redrawn.</a:t>
+              <a:t>VERDICT: FAIL g2_min=0.4305 g2_median=0.7076 diag_g2_min=0.4305 diag_g2_median=0.7409 flux_max=1111 flux_shortfall=0.9001 median_pass=false coverage=0.02083 eligible=16/192 flux_floor_excluded=176 evidence=incomplete conditional=true headline_coverage=4/192 cw_raw_coverage=0/192 gamma300_pass_max=6</a:t>
+            </a:r>
+          </a:p>
+          <a:p>
+            <a:r>
+              <a:t>The sweep was generated by scripts/run_rt_edge.py (2026-09-06T07:06:37.352639+00:00) over the full contract-declared grid (docs/rt_edge_contract.md): dot.delta_xx in [4.0, 7.0] meV, dot.gamma300 in [6.0, 20.0] meV, and the detector response (IRF) in [50, 200] ps, evaluated for both the primary (GaAsP-well) and fallback (GaInP-well) design cards. This plot is constructed directly from out/rt_edge/sweep.csv at the largest splitting; the Chatzarakis 2023 and Matsuda 2001 anchors are read from the shared evidence ledger. The linewidth is unmeasured for this InP platform.</a:t>
             </a:r>
           </a:p>
         </p:txBody>
@@ -945,24 +945,7 @@
           <a:lstStyle/>
           <a:p>
             <a:r>
-              <a:t>CARD: edge-inp-gaasp-design role=primary g2_pulsed_min=0.4117 g2_pulsed_median=0.8555 g2_cw_raw_min=0.9784 g2_cw_raw_median=0.9992 eligible=27/27 favorable_rows=0</a:t>
-            </a:r>
-          </a:p>
-          <a:p>
-            <a:r>
-              <a:t>CARD: edge-inp-gainp-design role=fallback g2_pulsed_min=0.3648 g2_pulsed_median=0.7325 g2_cw_raw_min=0.8907 g2_cw_raw_median=0.9926 eligible=27/27 favorable_rows=0</a:t>
-            </a:r>
-          </a:p>
-          <a:p/>
-          <a:p>
-            <a:r>
-              <a:t>No published III-V quantum dot has demonstrated g2(0) &lt; 0.5 at 300 K under electrical driving; the best reported room-temperature values sit around 0.5-0.57 (docs/rt_edge_contract.md Evidence section; verify/data/rt_edge_anchors.yaml). This sweep's pooled pulsed g2_min=0.3648, g2_median=0.773 is reported against that ceiling, not as a claim of having exceeded it.</a:t>
-            </a:r>
-          </a:p>
-          <a:p/>
-          <a:p>
-            <a:r>
-              <a:t>Why pulsed and continuous drive disagree so sharply: at 300 K, thermally activated carrier escape from the dot happens on a picosecond timescale (fsim_core.dot_levels retention model, InP/(Al,Ga)InP activation energies from Bommer et al. 2011 and Schulz et al., physica status solidi (c) 6, 906 (2009)). Under continuous electrical drive this makes the antibunching dip itself narrower than any real single-photon detector's 50-200 ps timing response, so the measured (IRF-convolved) CW g2 stays near 1 even though the intrinsic CW g2 can be favourable -- see the g2_cw0 vs g2_cw0_raw columns of out/rt_edge/sweep.csv. Pulsed operation, which asks only about the photon statistics within one short injection pulse, is required to see any single-photon character at all in this design.</a:t>
+              <a:t>The factor table is read from out/rt_edge/verdict.md: loading=0.632121, t_X=0.5, retention=0.00461745, eta_total=0.00951594, and repetition rate=8e+07 Hz. These levers buy enough collection for only the fallback low-linewidth corner; they do not improve intrinsic g2. The floor, factors, and lever values are the acceptance artifact's brightness decomposition.</a:t>
             </a:r>
           </a:p>
         </p:txBody>
@@ -1032,7 +1015,7 @@
           <a:lstStyle/>
           <a:p>
             <a:r>
-              <a:t>verify/verify_rt_edge_papers.py is a self-contained hallucination check: it re-derives every anchored literature claim from the shared evidence ledger (verify/data/rt_edge_anchors.yaml), confirms each has a real DOI or figure locator, checks units and plausible magnitude, and distinguishes raw-versus-background-corrected numbers (a documented failure mode where a paper's own raw, deconvolved and fully-corrected values could be swapped). It currently passes 14/16 checks. Two claims still lack the required second, independent verified source and are reported as incomplete rather than silently accepted: reischle2008_g2_80K (only 0 distinct verified primary source(s), need 2); hkust_inp_gaasp_wavelength (only 0 distinct verified primary source(s), need 2). For context, the 80 K claim's only source is Reischle et al., Optics Express 16, 12771 (2008), and the wavelength claim's only source is Gu et al., Optics Express 33, 23732 (2025).</a:t>
+              <a:t>verify/verify_rt_edge_papers.py is a self-contained hallucination check: it re-derives every anchored literature claim from the shared evidence ledger (verify/data/rt_edge_anchors.yaml), confirms each has a real DOI or figure locator, checks units and plausible magnitude, and distinguishes raw-versus-background-corrected numbers (a documented failure mode where a paper's own raw, deconvolved and fully-corrected values could be swapped). It currently passes 14/17 checks. Two claims still lack the required second, independent verified source and are reported as incomplete rather than silently accepted: reischle2008_g2_80K (only 0 distinct verified primary source(s), need 2); hkust_inp_gaasp_wavelength (only 1 distinct verified primary source(s), need 2); residual_background_80K (only 1 distinct verified primary source(s), need 2). For context, the 80 K claim's only source is Reischle et al., Optics Express 16, 12771 (2008), and the wavelength claim's only source is Gu et al., Optics Express 33, 23732 (2025).</a:t>
             </a:r>
           </a:p>
         </p:txBody>
@@ -1172,12 +1155,12 @@
           <a:lstStyle/>
           <a:p>
             <a:r>
-              <a:t>VERDICT: FAIL g2_min=0.3648 g2_median=0.773 median_pass=false coverage=0 eligible=54/54 evidence=incomplete conditional=false</a:t>
-            </a:r>
-          </a:p>
-          <a:p>
-            <a:r>
-              <a:t>Fail reasons: evidence_incomplete, no_favorable_corner_metrics. The stop rule set at the start of this project (g2(0) &lt; 0.5 at 300 K, working electrical injection, in-plane out-coupling, every claim cross-checked against at least two independent papers, and all hallucination tests passing) is not met: no single row of the 54-point sweep clears the pulsed g2, CW intrinsic g2 and CW measured g2 gates simultaneously, and two evidence-ledger claims still rest on one source each. This is reported as a fail, not reframed as a conditional pass, because docs/rt_edge_contract.md makes evidence completeness and a same-row favourable corner both mandatory, and because no published III-V quantum dot -- at any drive scheme -- has demonstrated g2(0) &lt; 0.5 at 300 K under electrical driving.</a:t>
+              <a:t>VERDICT: FAIL g2_min=0.4305 g2_median=0.7076 diag_g2_min=0.4305 diag_g2_median=0.7409 flux_max=1111 flux_shortfall=0.9001 median_pass=false coverage=0.02083 eligible=16/192 flux_floor_excluded=176 evidence=incomplete conditional=true headline_coverage=4/192 cw_raw_coverage=0/192 gamma300_pass_max=6</a:t>
+            </a:r>
+          </a:p>
+          <a:p>
+            <a:r>
+              <a:t>Fail reasons: evidence_incomplete. The stop rule set at the start of this project (g2(0) &lt; 0.5 at 300 K, working electrical injection, in-plane out-coupling, every claim cross-checked against at least two independent papers, and all hallucination tests passing) is not met. Four eligible rows of the 192-row sweep clear the pulsed headline only at gamma300=6 meV and with declared collection levers, while evidence claims still lack independent support. This remains a FAIL rather than a conditional PASS because docs/rt_edge_contract.md makes evidence completeness mandatory, and because no published III-V quantum dot -- at any drive scheme -- has demonstrated g2(0) &lt; 0.5 at 300 K under electrical driving.</a:t>
             </a:r>
           </a:p>
         </p:txBody>
@@ -1597,7 +1580,7 @@
           <a:lstStyle/>
           <a:p>
             <a:r>
-              <a:t>qd-photon-sim is a simulator: given a 'design card' describing a dot, its host materials, the drive electronics and the output waveguide, it predicts the single-photon purity g2(0), the collected brightness, and the temperature/current window over which the design would work -- all built up from published material constants (lattice constants, band gaps, effective masses, linewidths) rather than tuned to produce a desired answer. A companion module (verify/verify_rt_edge_papers.py) independently re-checks every cited literature number for unit errors, out-of-range values, and duplicated or unsourced citations; the current evidence ledger passes 14/16 such checks.</a:t>
+              <a:t>qd-photon-sim is a simulator: given a 'design card' describing a dot, its host materials, the drive electronics and the output waveguide, it predicts the single-photon purity g2(0), the collected brightness, and the temperature/current window over which the design would work -- all built up from published material constants (lattice constants, band gaps, effective masses, linewidths) rather than tuned to produce a desired answer. A companion module (verify/verify_rt_edge_papers.py) independently re-checks every cited literature number for unit errors, out-of-range values, and duplicated or unsourced citations; the current evidence ledger passes 14/17 such checks.</a:t>
             </a:r>
           </a:p>
         </p:txBody>
@@ -5048,7 +5031,7 @@
               </a:defRPr>
             </a:pPr>
             <a:r>
-              <a:t>• At this design's operating current the junction sits near 1.28 V forward bias</a:t>
+              <a:t>• At this design's operating current the junction sits near 1.50 V forward bias</a:t>
             </a:r>
           </a:p>
         </p:txBody>
@@ -5315,7 +5298,7 @@
               </a:defRPr>
             </a:pPr>
             <a:r>
-              <a:t>• This design's mode captures about 1.8-1.9% of the dot's light (beta)</a:t>
+              <a:t>• This design's mode captures about 2.9-2.9% of the dot's light (beta)</a:t>
             </a:r>
           </a:p>
           <a:p>
@@ -5330,7 +5313,7 @@
               </a:defRPr>
             </a:pPr>
             <a:r>
-              <a:t>• An uncoated facet lets about 70% of that light escape the chip</a:t>
+              <a:t>• An uncoated facet lets about 73% of that light escape the chip</a:t>
             </a:r>
           </a:p>
         </p:txBody>
@@ -5471,7 +5454,7 @@
               </a:defRPr>
             </a:pPr>
             <a:r>
-              <a:t>• This design's best pulsed corner reaches 0.3648, only at the narrow-line, wide-splitting extreme</a:t>
+              <a:t>• This design's best pulsed corner reaches 0.4305, only at the narrow-line, wide-splitting extreme</a:t>
             </a:r>
           </a:p>
         </p:txBody>
@@ -5521,6 +5504,181 @@
                 </a:solidFill>
               </a:rPr>
               <a:t>Results: the room-temperature acceptance sweep</a:t>
+            </a:r>
+          </a:p>
+        </p:txBody>
+      </p:sp>
+      <p:pic>
+        <p:nvPicPr>
+          <p:cNvPr id="3" name="Picture 2" descr="linewidth_sweep.png"/>
+          <p:cNvPicPr>
+            <a:picLocks noChangeAspect="1"/>
+          </p:cNvPicPr>
+          <p:nvPr/>
+        </p:nvPicPr>
+        <p:blipFill>
+          <a:blip r:embed="rId2"/>
+          <a:stretch>
+            <a:fillRect/>
+          </a:stretch>
+        </p:blipFill>
+        <p:spPr>
+          <a:xfrm>
+            <a:off x="5699455" y="2239165"/>
+            <a:ext cx="6035040" cy="3385510"/>
+          </a:xfrm>
+          <a:prstGeom prst="rect">
+            <a:avLst/>
+          </a:prstGeom>
+        </p:spPr>
+      </p:pic>
+      <p:sp>
+        <p:nvSpPr>
+          <p:cNvPr id="4" name="TextBox 3"/>
+          <p:cNvSpPr txBox="1"/>
+          <p:nvPr/>
+        </p:nvSpPr>
+        <p:spPr>
+          <a:xfrm>
+            <a:off x="548640" y="1234440"/>
+            <a:ext cx="5212080" cy="5394960"/>
+          </a:xfrm>
+          <a:prstGeom prst="rect">
+            <a:avLst/>
+          </a:prstGeom>
+          <a:noFill/>
+        </p:spPr>
+        <p:txBody>
+          <a:bodyPr wrap="square">
+            <a:spAutoFit/>
+          </a:bodyPr>
+          <a:lstStyle/>
+          <a:p>
+            <a:pPr>
+              <a:spcAft>
+                <a:spcPts val="1000"/>
+              </a:spcAft>
+              <a:defRPr sz="1800">
+                <a:solidFill>
+                  <a:srgbClr val="1B1F24"/>
+                </a:solidFill>
+              </a:defRPr>
+            </a:pPr>
+            <a:r>
+              <a:t>• At the best 7 meV splitting, pulsed g2 rises with linewidth</a:t>
+            </a:r>
+          </a:p>
+          <a:p>
+            <a:pPr>
+              <a:spcAft>
+                <a:spcPts val="1000"/>
+              </a:spcAft>
+              <a:defRPr sz="1800">
+                <a:solidFill>
+                  <a:srgbClr val="1B1F24"/>
+                </a:solidFill>
+              </a:defRPr>
+            </a:pPr>
+            <a:r>
+              <a:t>• The 0.5 line is crossed only at the low-linewidth end</a:t>
+            </a:r>
+          </a:p>
+          <a:p>
+            <a:pPr>
+              <a:spcAft>
+                <a:spcPts val="1000"/>
+              </a:spcAft>
+              <a:defRPr sz="1800">
+                <a:solidFill>
+                  <a:srgbClr val="1B1F24"/>
+                </a:solidFill>
+              </a:defRPr>
+            </a:pPr>
+            <a:r>
+              <a:t>• Verified class anchors: 6.5 and 12 meV</a:t>
+            </a:r>
+          </a:p>
+        </p:txBody>
+      </p:sp>
+      <p:sp>
+        <p:nvSpPr>
+          <p:cNvPr id="5" name="TextBox 4"/>
+          <p:cNvSpPr txBox="1"/>
+          <p:nvPr/>
+        </p:nvSpPr>
+        <p:spPr>
+          <a:xfrm>
+            <a:off x="548640" y="5806440"/>
+            <a:ext cx="5212080" cy="777240"/>
+          </a:xfrm>
+          <a:prstGeom prst="rect">
+            <a:avLst/>
+          </a:prstGeom>
+          <a:noFill/>
+        </p:spPr>
+        <p:txBody>
+          <a:bodyPr wrap="square">
+            <a:spAutoFit/>
+          </a:bodyPr>
+          <a:lstStyle/>
+          <a:p>
+            <a:r>
+              <a:rPr sz="1300">
+                <a:solidFill>
+                  <a:srgbClr val="57606A"/>
+                </a:solidFill>
+                <a:latin typeface="Consolas"/>
+              </a:rPr>
+              <a:t>VERDICT: FAIL g2_min=0.4305 g2_median=0.7076 diag_g2_min=0.4305 diag_g2_median=0.7409 flux_max=1111 flux_shortfall=0.9001 median_pass=false coverage=0.02083 eligible=16/192 flux_floor_excluded=176 evidence=incomplete conditional=true headline_coverage=4/192 cw_raw_coverage=0/192 gamma300_pass_max=6</a:t>
+            </a:r>
+          </a:p>
+        </p:txBody>
+      </p:sp>
+    </p:spTree>
+  </p:cSld>
+  <p:clrMapOvr>
+    <a:masterClrMapping/>
+  </p:clrMapOvr>
+</p:sld>
+</file>
+
+<file path=ppt/slides/slide15.xml><?xml version="1.0" encoding="utf-8"?>
+<p:sld xmlns:a="http://schemas.openxmlformats.org/drawingml/2006/main" xmlns:p="http://schemas.openxmlformats.org/presentationml/2006/main" xmlns:r="http://schemas.openxmlformats.org/officeDocument/2006/relationships">
+  <p:cSld>
+    <p:spTree>
+      <p:nvGrpSpPr>
+        <p:cNvPr id="1" name=""/>
+        <p:cNvGrpSpPr/>
+        <p:nvPr/>
+      </p:nvGrpSpPr>
+      <p:grpSpPr/>
+      <p:sp>
+        <p:nvSpPr>
+          <p:cNvPr id="2" name="Title 1"/>
+          <p:cNvSpPr>
+            <a:spLocks noGrp="1"/>
+          </p:cNvSpPr>
+          <p:nvPr>
+            <p:ph type="title"/>
+          </p:nvPr>
+        </p:nvSpPr>
+        <p:spPr>
+          <a:xfrm>
+            <a:off x="457200" y="228600"/>
+            <a:ext cx="11277295" cy="914400"/>
+          </a:xfrm>
+        </p:spPr>
+        <p:txBody>
+          <a:bodyPr/>
+          <a:lstStyle/>
+          <a:p>
+            <a:r>
+              <a:rPr sz="3600" b="1">
+                <a:solidFill>
+                  <a:srgbClr val="1B1F24"/>
+                </a:solidFill>
+              </a:rPr>
+              <a:t>Why brightness changes the answer</a:t>
             </a:r>
           </a:p>
         </p:txBody>
@@ -5582,7 +5740,7 @@
               </a:defRPr>
             </a:pPr>
             <a:r>
-              <a:t>• Sweep: 54 evaluated configurations, spanning the dot's linewidth, its X-XX splitting, and the detector response time</a:t>
+              <a:t>• Flux floor: 1000 photons/s; 176 of 192 rows are excluded below it</a:t>
             </a:r>
           </a:p>
           <a:p>
@@ -5597,139 +5755,9 @@
               </a:defRPr>
             </a:pPr>
             <a:r>
-              <a:t>• Every corner is checked against three gates at once: pulsed g2, CW intrinsic g2, CW measured g2</a:t>
-            </a:r>
-          </a:p>
-        </p:txBody>
-      </p:sp>
-      <p:sp>
-        <p:nvSpPr>
-          <p:cNvPr id="5" name="TextBox 4"/>
-          <p:cNvSpPr txBox="1"/>
-          <p:nvPr/>
-        </p:nvSpPr>
-        <p:spPr>
-          <a:xfrm>
-            <a:off x="548640" y="5806440"/>
-            <a:ext cx="5212080" cy="777240"/>
-          </a:xfrm>
-          <a:prstGeom prst="rect">
-            <a:avLst/>
-          </a:prstGeom>
-          <a:noFill/>
-        </p:spPr>
-        <p:txBody>
-          <a:bodyPr wrap="square">
-            <a:spAutoFit/>
-          </a:bodyPr>
-          <a:lstStyle/>
-          <a:p>
-            <a:r>
-              <a:rPr sz="1300">
-                <a:solidFill>
-                  <a:srgbClr val="57606A"/>
-                </a:solidFill>
-                <a:latin typeface="Consolas"/>
-              </a:rPr>
-              <a:t>VERDICT: FAIL g2_min=0.3648 g2_median=0.773 median_pass=false coverage=0 eligible=54/54 evidence=incomplete conditional=false</a:t>
-            </a:r>
-          </a:p>
-        </p:txBody>
-      </p:sp>
-    </p:spTree>
-  </p:cSld>
-  <p:clrMapOvr>
-    <a:masterClrMapping/>
-  </p:clrMapOvr>
-</p:sld>
-</file>
-
-<file path=ppt/slides/slide15.xml><?xml version="1.0" encoding="utf-8"?>
-<p:sld xmlns:a="http://schemas.openxmlformats.org/drawingml/2006/main" xmlns:p="http://schemas.openxmlformats.org/presentationml/2006/main" xmlns:r="http://schemas.openxmlformats.org/officeDocument/2006/relationships">
-  <p:cSld>
-    <p:spTree>
-      <p:nvGrpSpPr>
-        <p:cNvPr id="1" name=""/>
-        <p:cNvGrpSpPr/>
-        <p:nvPr/>
-      </p:nvGrpSpPr>
-      <p:grpSpPr/>
-      <p:sp>
-        <p:nvSpPr>
-          <p:cNvPr id="2" name="Title 1"/>
-          <p:cNvSpPr>
-            <a:spLocks noGrp="1"/>
-          </p:cNvSpPr>
-          <p:nvPr>
-            <p:ph type="title"/>
-          </p:nvPr>
-        </p:nvSpPr>
-        <p:spPr>
-          <a:xfrm>
-            <a:off x="457200" y="228600"/>
-            <a:ext cx="11277295" cy="914400"/>
-          </a:xfrm>
-        </p:spPr>
-        <p:txBody>
-          <a:bodyPr/>
-          <a:lstStyle/>
-          <a:p>
-            <a:r>
-              <a:rPr sz="3600" b="1">
-                <a:solidFill>
-                  <a:srgbClr val="1B1F24"/>
-                </a:solidFill>
-              </a:rPr>
-              <a:t>Results in detail: pulsed vs continuous drive</a:t>
-            </a:r>
-          </a:p>
-        </p:txBody>
-      </p:sp>
-      <p:pic>
-        <p:nvPicPr>
-          <p:cNvPr id="3" name="Picture 2" descr="envelope.png"/>
-          <p:cNvPicPr>
-            <a:picLocks noChangeAspect="1"/>
-          </p:cNvPicPr>
-          <p:nvPr/>
-        </p:nvPicPr>
-        <p:blipFill>
-          <a:blip r:embed="rId2"/>
-          <a:stretch>
-            <a:fillRect/>
-          </a:stretch>
-        </p:blipFill>
-        <p:spPr>
-          <a:xfrm>
-            <a:off x="5699455" y="2670048"/>
-            <a:ext cx="6035040" cy="2523744"/>
-          </a:xfrm>
-          <a:prstGeom prst="rect">
-            <a:avLst/>
-          </a:prstGeom>
-        </p:spPr>
-      </p:pic>
-      <p:sp>
-        <p:nvSpPr>
-          <p:cNvPr id="4" name="TextBox 3"/>
-          <p:cNvSpPr txBox="1"/>
-          <p:nvPr/>
-        </p:nvSpPr>
-        <p:spPr>
-          <a:xfrm>
-            <a:off x="548640" y="1234440"/>
-            <a:ext cx="5212080" cy="5394960"/>
-          </a:xfrm>
-          <a:prstGeom prst="rect">
-            <a:avLst/>
-          </a:prstGeom>
-          <a:noFill/>
-        </p:spPr>
-        <p:txBody>
-          <a:bodyPr wrap="square">
-            <a:spAutoFit/>
-          </a:bodyPr>
-          <a:lstStyle/>
+              <a:t>• The declared HR back facet, NA 0.75 and 250 um ridge produce the eligible corner</a:t>
+            </a:r>
+          </a:p>
           <a:p>
             <a:pPr>
               <a:spcAft>
@@ -5742,22 +5770,7 @@
               </a:defRPr>
             </a:pPr>
             <a:r>
-              <a:t>• Pulsed drive can beat the literature ceiling at one extreme corner; continuous drive never does</a:t>
-            </a:r>
-          </a:p>
-          <a:p>
-            <a:pPr>
-              <a:spcAft>
-                <a:spcPts val="1000"/>
-              </a:spcAft>
-              <a:defRPr sz="1800">
-                <a:solidFill>
-                  <a:srgbClr val="1B1F24"/>
-                </a:solidFill>
-              </a:defRPr>
-            </a:pPr>
-            <a:r>
-              <a:t>• Carriers escape the dot in picoseconds at 300 K -- faster than any real detector can resolve</a:t>
+              <a:t>• Maximum collected flux is 1111 photons/s photons/s</a:t>
             </a:r>
           </a:p>
         </p:txBody>
@@ -5806,7 +5819,7 @@
                   <a:srgbClr val="1B1F24"/>
                 </a:solidFill>
               </a:rPr>
-              <a:t>Checking the numbers against the literature</a:t>
+              <a:t>Validation: 80 K and 230 K comparisons</a:t>
             </a:r>
           </a:p>
         </p:txBody>
@@ -5844,7 +5857,7 @@
               </a:defRPr>
             </a:pPr>
             <a:r>
-              <a:t>• Every literature number is tagged: verified, derived, class estimate, or assumption</a:t>
+              <a:t>• 80 K model comparison: g2(0)=0.25 +/- 0.05 and about 4000 counts/s</a:t>
             </a:r>
           </a:p>
           <a:p>
@@ -5859,7 +5872,7 @@
               </a:defRPr>
             </a:pPr>
             <a:r>
-              <a:t>• An automatic check confirms every citation is real, in range and in context (14/16 checks passed)</a:t>
+              <a:t>• Reischle 2008: raw g2(0)=0.43; corrected g2(0)=0.03</a:t>
             </a:r>
           </a:p>
           <a:p>
@@ -5874,7 +5887,7 @@
               </a:defRPr>
             </a:pPr>
             <a:r>
-              <a:t>• Two claims still have only one independent source and are honestly marked incomplete</a:t>
+              <a:t>• 230 K model comparison: g2(0)=0.36, matching Chatzarakis 2023</a:t>
             </a:r>
           </a:p>
         </p:txBody>
@@ -6102,7 +6115,7 @@
               </a:defRPr>
             </a:pPr>
             <a:r>
-              <a:t>• This design does not pass the room-temperature stop rule</a:t>
+              <a:t>• The stop rule is not met as stated: this is a conditional model corner, not a PASS</a:t>
             </a:r>
           </a:p>
           <a:p>
@@ -6117,7 +6130,7 @@
               </a:defRPr>
             </a:pPr>
             <a:r>
-              <a:t>• Fail reasons: no corner clears all three gates together; two literature claims are still single-sourced</a:t>
+              <a:t>• PASS needs a measured 300 K InP-dot linewidth at or below about 7 meV</a:t>
             </a:r>
           </a:p>
           <a:p>
@@ -6166,7 +6179,7 @@
                 </a:solidFill>
                 <a:latin typeface="Consolas"/>
               </a:rPr>
-              <a:t>VERDICT: FAIL g2_min=0.3648 g2_median=0.773 median_pass=false coverage=0 eligible=54/54 evidence=incomplete conditional=false</a:t>
+              <a:t>VERDICT: FAIL g2_min=0.4305 g2_median=0.7076 diag_g2_min=0.4305 diag_g2_median=0.7409 flux_max=1111 flux_shortfall=0.9001 median_pass=false coverage=0.02083 eligible=16/192 flux_floor_excluded=176 evidence=incomplete conditional=true headline_coverage=4/192 cw_raw_coverage=0/192 gamma300_pass_max=6</a:t>
             </a:r>
           </a:p>
         </p:txBody>
@@ -6253,7 +6266,7 @@
               </a:defRPr>
             </a:pPr>
             <a:r>
-              <a:t>• A narrower 300 K linewidth or a larger X-XX splitting would help most (out/rt_edge/gui-smoke.png.txt)</a:t>
+              <a:t>• Filter window follows the linewidth, fixing t_X=0.5 by convention</a:t>
             </a:r>
           </a:p>
           <a:p>
@@ -6268,7 +6281,7 @@
               </a:defRPr>
             </a:pPr>
             <a:r>
-              <a:t>• No InP/GaAsP single-dot measurement exists yet; today's linewidth and splitting are class proxies</a:t>
+              <a:t>• Residual background is transferred from 80 K data to this 300 K platform</a:t>
             </a:r>
           </a:p>
           <a:p>
@@ -6283,7 +6296,7 @@
               </a:defRPr>
             </a:pPr>
             <a:r>
-              <a:t>• A second independent source would close the evidence gate</a:t>
+              <a:t>• Pulsed drive is required: the CW dip is narrower than detector response</a:t>
             </a:r>
           </a:p>
         </p:txBody>

</xml_diff>

<commit_message>
RT edge tier: docs, README and presentation refreshed to the round-5 verdict
Co-Authored-By: Claude Fable 5.1 <noreply@anthropic.com>
Claude-Session: https://claude.ai/code/session_01BQ7efTVkjp2fGYyjphSZC9
</commit_message>
<xml_diff>
--- a/out/presentation/qd_edge_sps.pptx
+++ b/out/presentation/qd_edge_sps.pptx
@@ -800,7 +800,7 @@
           <a:lstStyle/>
           <a:p>
             <a:r>
-              <a:t>g2(0) is the only equation this deck states explicitly, and even it is explained rather than derived: it is the probability of detecting two photons at (almost) the same instant, normalized so that a classical, many-photon source gives 1 and a perfect single-photon emitter gives 0. The dashed curve on this slide is the published 300 K ceiling (no electrically or optically driven III-V dot has ever demonstrated g2(0) &lt; 0.5 at 300 K, docs/rt_edge_contract.md); the solid curve is this design's own best pulsed-drive corner from the acceptance sweep, g2 = 0.4305 -- better than the published ceiling, but only at the extreme corner of the swept range (narrowest linewidth, widest X-XX splitting) and only under pulsed, not continuous, drive.</a:t>
+              <a:t>g2(0) is the only equation this deck states explicitly, and even it is explained rather than derived: it is the probability of detecting two photons at (almost) the same instant, normalized so that a classical, many-photon source gives 1 and a perfect single-photon emitter gives 0. The dashed curve on this slide is the published 300 K ceiling (no electrically or optically driven III-V dot has ever demonstrated g2(0) &lt; 0.5 at 300 K, docs/rt_edge_contract.md); the solid curve is this design's own best pulsed-drive corner from the acceptance sweep, g2 = 0.3986 -- better than the published ceiling, but only at the extreme corner of the swept range (narrowest linewidth, widest X-XX splitting) and only under pulsed, not continuous, drive.</a:t>
             </a:r>
           </a:p>
         </p:txBody>
@@ -870,12 +870,12 @@
           <a:lstStyle/>
           <a:p>
             <a:r>
-              <a:t>VERDICT: FAIL g2_min=0.4305 g2_median=0.7076 diag_g2_min=0.4305 diag_g2_median=0.7409 flux_max=1111 flux_shortfall=0.9001 median_pass=false coverage=0.02083 eligible=16/192 flux_floor_excluded=176 evidence=incomplete conditional=true headline_coverage=4/192 cw_raw_coverage=0/192 gamma300_pass_max=6</a:t>
-            </a:r>
-          </a:p>
-          <a:p>
-            <a:r>
-              <a:t>The sweep was generated by scripts/run_rt_edge.py (2026-09-06T07:06:37.352639+00:00) over the full contract-declared grid (docs/rt_edge_contract.md): dot.delta_xx in [4.0, 7.0] meV, dot.gamma300 in [6.0, 20.0] meV, and the detector response (IRF) in [50, 200] ps, evaluated for both the primary (GaAsP-well) and fallback (GaInP-well) design cards. This plot is constructed directly from out/rt_edge/sweep.csv at the largest splitting; the Chatzarakis 2023 and Matsuda 2001 anchors are read from the shared evidence ledger. The linewidth is unmeasured for this InP platform.</a:t>
+              <a:t>VERDICT: FAIL g2_min=0.3986 g2_median_eligible=0.7019 diag_g2_min=0.3986 diag_g2_median_diagnostic=0.7352 flux_max=1544 flux_margin=1.544 flux_shortfall_deprecated=0.6475 median_pass=false coverage_over_eligible=0.25 eligible_fraction=0.1667 eligible=32/192 flux_floor_excluded=160 evidence=incomplete conditional=true headline_coverage=8/192 cw_raw_coverage=0/192 gamma300_pass_max=8 gamma300_threshold=8-10</a:t>
+            </a:r>
+          </a:p>
+          <a:p>
+            <a:r>
+              <a:t>The sweep was generated by scripts/run_rt_edge.py (2026-09-06T08:59:19.106139+00:00) over the full contract-declared grid (docs/rt_edge_contract.md): dot.delta_xx in [4.0, 8.0] meV, dot.gamma300 sampled at the finer values present in sweep.csv, and the detector response (IRF) in [50, 200] ps, evaluated for both the primary (GaAsP-well) and fallback (GaInP-well) design cards. This plot is constructed directly from out/rt_edge/sweep.csv at the largest splitting; the Chatzarakis 2023 and Matsuda 2001 anchors are read from the shared evidence ledger. At the 6.5 meV anchor:  The linewidth is unmeasured for this InP platform. Facet-model note: **Independent check on the combined front-facet factor** (council review round 5, item 6, fixing a tautology): the value above is BACK-SOLVED -- the one factor missing once eta_total, beta, propagation and NA are all already known (eta_total = beta * &lt;combined factor&gt; * eta_prop * eta_NA) -- so a self-check comparing it against that same back-solving would only ever reproduce its own inputs. The genuinely independent check instead recomputes the combined factor FORWARD from this row's own facet transmission (T_facet) and back-facet reflectivity (R_back), trying every candidate formula introspected LIVE from fsim_core/waveguide.py's installed `edge_emission` source right now (never hardcoded, since that file's facet model is being edited concurrently and may change again) -- both as a fused current-model factor and as a legacy front-split-times-T_facet factor, since either grouping may be in effect: forward = 0.935012 via `facet_factor = T / (T + (1 - R_back))` (fused/current-model convention: already includes T_facet), back-solved = 0.935012 -- MATCH (agreement confirms the back-solved value really is the geometric front/back-facet-and-transmission factor waveguide.py computes, not some other quantity folded into eta_total).</a:t>
             </a:r>
           </a:p>
         </p:txBody>
@@ -945,7 +945,7 @@
           <a:lstStyle/>
           <a:p>
             <a:r>
-              <a:t>The factor table is read from out/rt_edge/verdict.md: loading=0.632121, t_X=0.5, retention=0.00461745, eta_total=0.00951594, and repetition rate=8e+07 Hz. These levers buy enough collection for only the fallback low-linewidth corner; they do not improve intrinsic g2. The floor, factors, and lever values are the acceptance artifact's brightness decomposition.</a:t>
+              <a:t>The factor table is read from out/rt_edge/verdict.md: loading=0.632121, t_X=0.5, retention=0.00461745, eta_total=0.0132281, and repetition rate=8e+07 Hz. These levers buy enough collection for only the fallback low-linewidth corner; they do not improve intrinsic g2. The floor, factors, and lever values are the acceptance artifact's brightness decomposition. Facet-model note from the verdict: **Independent check on the combined front-facet factor** (council review round 5, item 6, fixing a tautology): the value above is BACK-SOLVED -- the one factor missing once eta_total, beta, propagation and NA are all already known (eta_total = beta * &lt;combined factor&gt; * eta_prop * eta_NA) -- so a self-check comparing it against that same back-solving would only ever reproduce its own inputs. The genuinely independent check instead recomputes the combined factor FORWARD from this row's own facet transmission (T_facet) and back-facet reflectivity (R_back), trying every candidate formula introspected LIVE from fsim_core/waveguide.py's installed `edge_emission` source right now (never hardcoded, since that file's facet model is being edited concurrently and may change again) -- both as a fused current-model factor and as a legacy front-split-times-T_facet factor, since either grouping may be in effect: forward = 0.935012 via `facet_factor = T / (T + (1 - R_back))` (fused/current-model convention: already includes T_facet), back-solved = 0.935012 -- MATCH (agreement confirms the back-solved value really is the geometric front/back-facet-and-transmission factor waveguide.py computes, not some other quantity folded into eta_total).</a:t>
             </a:r>
           </a:p>
         </p:txBody>
@@ -1155,12 +1155,12 @@
           <a:lstStyle/>
           <a:p>
             <a:r>
-              <a:t>VERDICT: FAIL g2_min=0.4305 g2_median=0.7076 diag_g2_min=0.4305 diag_g2_median=0.7409 flux_max=1111 flux_shortfall=0.9001 median_pass=false coverage=0.02083 eligible=16/192 flux_floor_excluded=176 evidence=incomplete conditional=true headline_coverage=4/192 cw_raw_coverage=0/192 gamma300_pass_max=6</a:t>
-            </a:r>
-          </a:p>
-          <a:p>
-            <a:r>
-              <a:t>Fail reasons: evidence_incomplete. The stop rule set at the start of this project (g2(0) &lt; 0.5 at 300 K, working electrical injection, in-plane out-coupling, every claim cross-checked against at least two independent papers, and all hallucination tests passing) is not met. Four eligible rows of the 192-row sweep clear the pulsed headline only at gamma300=6 meV and with declared collection levers, while evidence claims still lack independent support. This remains a FAIL rather than a conditional PASS because docs/rt_edge_contract.md makes evidence completeness mandatory, and because no published III-V quantum dot -- at any drive scheme -- has demonstrated g2(0) &lt; 0.5 at 300 K under electrical driving.</a:t>
+              <a:t>VERDICT: FAIL g2_min=0.3986 g2_median_eligible=0.7019 diag_g2_min=0.3986 diag_g2_median_diagnostic=0.7352 flux_max=1544 flux_margin=1.544 flux_shortfall_deprecated=0.6475 median_pass=false coverage_over_eligible=0.25 eligible_fraction=0.1667 eligible=32/192 flux_floor_excluded=160 evidence=incomplete conditional=true headline_coverage=8/192 cw_raw_coverage=0/192 gamma300_pass_max=8 gamma300_threshold=8-10</a:t>
+            </a:r>
+          </a:p>
+          <a:p>
+            <a:r>
+              <a:t>Fail reasons: evidence_incomplete. The stop rule set at the start of this project (g2(0) &lt; 0.5 at 300 K, working electrical injection, in-plane out-coupling, every claim cross-checked against at least two independent papers, and all hallucination tests passing) is not met. The 6.5 meV per-card evaluation passes only for the fallback card; the primary card remains below the flux floor, while evidence claims still lack independent support. This remains a FAIL rather than a conditional PASS because docs/rt_edge_contract.md makes evidence completeness mandatory, and because no published III-V quantum dot -- at any drive scheme -- has demonstrated g2(0) &lt; 0.5 at 300 K under electrical driving.</a:t>
             </a:r>
           </a:p>
         </p:txBody>
@@ -5454,7 +5454,7 @@
               </a:defRPr>
             </a:pPr>
             <a:r>
-              <a:t>• This design's best pulsed corner reaches 0.4305, only at the narrow-line, wide-splitting extreme</a:t>
+              <a:t>• This design's best pulsed corner reaches 0.3986, only at the narrow-line, wide-splitting extreme</a:t>
             </a:r>
           </a:p>
         </p:txBody>
@@ -5565,7 +5565,7 @@
               </a:defRPr>
             </a:pPr>
             <a:r>
-              <a:t>• At the best 7 meV splitting, pulsed g2 rises with linewidth</a:t>
+              <a:t>• At the best 8 meV splitting, pulsed g2 rises with linewidth</a:t>
             </a:r>
           </a:p>
           <a:p>
@@ -5580,7 +5580,22 @@
               </a:defRPr>
             </a:pPr>
             <a:r>
-              <a:t>• The 0.5 line is crossed only at the low-linewidth end</a:t>
+              <a:t>• The threshold is bracketed at gamma300=8-10 meV; 6.5 meV is the per-card anchor</a:t>
+            </a:r>
+          </a:p>
+          <a:p>
+            <a:pPr>
+              <a:spcAft>
+                <a:spcPts val="1000"/>
+              </a:spcAft>
+              <a:defRPr sz="1800">
+                <a:solidFill>
+                  <a:srgbClr val="1B1F24"/>
+                </a:solidFill>
+              </a:defRPr>
+            </a:pPr>
+            <a:r>
+              <a:t>• The primary GaAsP card never clears the flux floor; the conditional result is fallback-only</a:t>
             </a:r>
           </a:p>
           <a:p>
@@ -5629,7 +5644,7 @@
                 </a:solidFill>
                 <a:latin typeface="Consolas"/>
               </a:rPr>
-              <a:t>VERDICT: FAIL g2_min=0.4305 g2_median=0.7076 diag_g2_min=0.4305 diag_g2_median=0.7409 flux_max=1111 flux_shortfall=0.9001 median_pass=false coverage=0.02083 eligible=16/192 flux_floor_excluded=176 evidence=incomplete conditional=true headline_coverage=4/192 cw_raw_coverage=0/192 gamma300_pass_max=6</a:t>
+              <a:t>VERDICT: FAIL g2_min=0.3986 g2_median_eligible=0.7019 diag_g2_min=0.3986 diag_g2_median_diagnostic=0.7352 flux_max=1544 flux_margin=1.544 flux_shortfall_deprecated=0.6475 median_pass=false coverage_over_eligible=0.25 eligible_fraction=0.1667 eligible=32/192 flux_floor_excluded=160 evidence=incomplete conditional=true headline_coverage=8/192 cw_raw_coverage=0/192 gamma300_pass_max=8 gamma300_threshold=8-10</a:t>
             </a:r>
           </a:p>
         </p:txBody>
@@ -5740,7 +5755,7 @@
               </a:defRPr>
             </a:pPr>
             <a:r>
-              <a:t>• Flux floor: 1000 photons/s; 176 of 192 rows are excluded below it</a:t>
+              <a:t>• Flux margin is 1.544; values above 1 clear the 1000 photons/s floor</a:t>
             </a:r>
           </a:p>
           <a:p>
@@ -5755,7 +5770,7 @@
               </a:defRPr>
             </a:pPr>
             <a:r>
-              <a:t>• The declared HR back facet, NA 0.75 and 250 um ridge produce the eligible corner</a:t>
+              <a:t>• The primary GaAsP card never clears the flux floor; only the fallback card supplies the conditional result</a:t>
             </a:r>
           </a:p>
           <a:p>
@@ -5770,7 +5785,7 @@
               </a:defRPr>
             </a:pPr>
             <a:r>
-              <a:t>• Maximum collected flux is 1111 photons/s photons/s</a:t>
+              <a:t>• Maximum collected flux is 1544.4 photons/s photons/s</a:t>
             </a:r>
           </a:p>
         </p:txBody>
@@ -5857,7 +5872,7 @@
               </a:defRPr>
             </a:pPr>
             <a:r>
-              <a:t>• 80 K model comparison: g2(0)=0.25 +/- 0.05 and about 4000 counts/s</a:t>
+              <a:t>• Reischle like-for-like: 0.25 +/- 0.05 deconvolved vs the model's best intrinsic corner</a:t>
             </a:r>
           </a:p>
           <a:p>
@@ -5872,7 +5887,7 @@
               </a:defRPr>
             </a:pPr>
             <a:r>
-              <a:t>• Reischle 2008: raw g2(0)=0.43; corrected g2(0)=0.03</a:t>
+              <a:t>• Reischle 2008 also reports raw g2(0)=0.43 and corrected g2(0)=0.03</a:t>
             </a:r>
           </a:p>
           <a:p>
@@ -6130,7 +6145,22 @@
               </a:defRPr>
             </a:pPr>
             <a:r>
-              <a:t>• PASS needs a measured 300 K InP-dot linewidth at or below about 7 meV</a:t>
+              <a:t>• PASS needs the measured linewidth to land inside the 8-10 meV threshold bracket</a:t>
+            </a:r>
+          </a:p>
+          <a:p>
+            <a:pPr>
+              <a:spcAft>
+                <a:spcPts val="1000"/>
+              </a:spcAft>
+              <a:defRPr sz="2200">
+                <a:solidFill>
+                  <a:srgbClr val="1B1F24"/>
+                </a:solidFill>
+              </a:defRPr>
+            </a:pPr>
+            <a:r>
+              <a:t>• The primary card never clears the flux floor; the conditional result rests on fallback alone</a:t>
             </a:r>
           </a:p>
           <a:p>
@@ -6179,7 +6209,7 @@
                 </a:solidFill>
                 <a:latin typeface="Consolas"/>
               </a:rPr>
-              <a:t>VERDICT: FAIL g2_min=0.4305 g2_median=0.7076 diag_g2_min=0.4305 diag_g2_median=0.7409 flux_max=1111 flux_shortfall=0.9001 median_pass=false coverage=0.02083 eligible=16/192 flux_floor_excluded=176 evidence=incomplete conditional=true headline_coverage=4/192 cw_raw_coverage=0/192 gamma300_pass_max=6</a:t>
+              <a:t>VERDICT: FAIL g2_min=0.3986 g2_median_eligible=0.7019 diag_g2_min=0.3986 diag_g2_median_diagnostic=0.7352 flux_max=1544 flux_margin=1.544 flux_shortfall_deprecated=0.6475 median_pass=false coverage_over_eligible=0.25 eligible_fraction=0.1667 eligible=32/192 flux_floor_excluded=160 evidence=incomplete conditional=true headline_coverage=8/192 cw_raw_coverage=0/192 gamma300_pass_max=8 gamma300_threshold=8-10</a:t>
             </a:r>
           </a:p>
         </p:txBody>

</xml_diff>

<commit_message>
RT edge tier: round 6 outputs, presentation rebuild, council history through pass 6
Co-Authored-By: Claude Fable 5.1 <noreply@anthropic.com>
Claude-Session: https://claude.ai/code/session_01BQ7efTVkjp2fGYyjphSZC9
</commit_message>
<xml_diff>
--- a/out/presentation/qd_edge_sps.pptx
+++ b/out/presentation/qd_edge_sps.pptx
@@ -875,7 +875,7 @@
           </a:p>
           <a:p>
             <a:r>
-              <a:t>The sweep was generated by scripts/run_rt_edge.py (2026-09-06T08:59:19.106139+00:00) over the full contract-declared grid (docs/rt_edge_contract.md): dot.delta_xx in [4.0, 8.0] meV, dot.gamma300 sampled at the finer values present in sweep.csv, and the detector response (IRF) in [50, 200] ps, evaluated for both the primary (GaAsP-well) and fallback (GaInP-well) design cards. This plot is constructed directly from out/rt_edge/sweep.csv at the largest splitting; the Chatzarakis 2023 and Matsuda 2001 anchors are read from the shared evidence ledger. At the 6.5 meV anchor:  The linewidth is unmeasured for this InP platform. Facet-model note: **Independent check on the combined front-facet factor** (council review round 5, item 6, fixing a tautology): the value above is BACK-SOLVED -- the one factor missing once eta_total, beta, propagation and NA are all already known (eta_total = beta * &lt;combined factor&gt; * eta_prop * eta_NA) -- so a self-check comparing it against that same back-solving would only ever reproduce its own inputs. The genuinely independent check instead recomputes the combined factor FORWARD from this row's own facet transmission (T_facet) and back-facet reflectivity (R_back), trying every candidate formula introspected LIVE from fsim_core/waveguide.py's installed `edge_emission` source right now (never hardcoded, since that file's facet model is being edited concurrently and may change again) -- both as a fused current-model factor and as a legacy front-split-times-T_facet factor, since either grouping may be in effect: forward = 0.935012 via `facet_factor = T / (T + (1 - R_back))` (fused/current-model convention: already includes T_facet), back-solved = 0.935012 -- MATCH (agreement confirms the back-solved value really is the geometric front/back-facet-and-transmission factor waveguide.py computes, not some other quantity folded into eta_total).</a:t>
+              <a:t>The sweep was generated by scripts/run_rt_edge.py (2026-09-06T10:12:38.980415+00:00) over the full contract-declared grid (docs/rt_edge_contract.md): dot.delta_xx in [4.0, 8.0] meV, dot.gamma300 sampled at the finer values present in sweep.csv, and the detector response (IRF) in [50, 200] ps, evaluated for both the primary (GaAsP-well) and fallback (GaInP-well) design cards. This plot is constructed directly from out/rt_edge/sweep.csv at the largest splitting; the Chatzarakis 2023 and Matsuda 2001 anchors are read from the shared evidence ledger. At the 6.5 meV anchor:  The linewidth is unmeasured for this InP platform. Facet-model note: **Independent check on the combined front-facet factor** (council review round 5, item 6, fixing a tautology): the value above is BACK-SOLVED -- the one factor missing once eta_total, beta, propagation and NA are all already known (eta_total = beta * &lt;combined factor&gt; * eta_prop * eta_NA) -- so a self-check comparing it against that same back-solving would only ever reproduce its own inputs. The genuinely independent check instead recomputes the combined factor FORWARD from this row's own facet transmission (T_facet) and back-facet reflectivity (R_back), trying every candidate formula introspected LIVE from fsim_core/waveguide.py's installed `edge_emission` source right now (never hardcoded, since that file's facet model is being edited concurrently and may change again) -- both as a fused current-model factor and as a legacy front-split-times-T_facet factor, since either grouping may be in effect: forward = 0.935012 via `facet_factor = T / (T + (1 - R_back))` (fused/current-model convention: already includes T_facet), back-solved = 0.935012 -- MATCH (agreement confirms the back-solved value really is the geometric front/back-facet-and-transmission factor waveguide.py computes, not some other quantity folded into eta_total).</a:t>
             </a:r>
           </a:p>
         </p:txBody>
@@ -1015,7 +1015,7 @@
           <a:lstStyle/>
           <a:p>
             <a:r>
-              <a:t>verify/verify_rt_edge_papers.py is a self-contained hallucination check: it re-derives every anchored literature claim from the shared evidence ledger (verify/data/rt_edge_anchors.yaml), confirms each has a real DOI or figure locator, checks units and plausible magnitude, and distinguishes raw-versus-background-corrected numbers (a documented failure mode where a paper's own raw, deconvolved and fully-corrected values could be swapped). It currently passes 14/17 checks. Two claims still lack the required second, independent verified source and are reported as incomplete rather than silently accepted: reischle2008_g2_80K (only 0 distinct verified primary source(s), need 2); hkust_inp_gaasp_wavelength (only 1 distinct verified primary source(s), need 2); residual_background_80K (only 1 distinct verified primary source(s), need 2). For context, the 80 K claim's only source is Reischle et al., Optics Express 16, 12771 (2008), and the wavelength claim's only source is Gu et al., Optics Express 33, 23732 (2025).</a:t>
+              <a:t>verify/verify_rt_edge_papers.py is a self-contained hallucination check: it re-derives every anchored literature claim from the shared evidence ledger (verify/data/rt_edge_anchors.yaml), confirms each has a real DOI or figure locator, checks units and plausible magnitude, and distinguishes raw-versus-background-corrected numbers (a documented failure mode where a paper's own raw, deconvolved and fully-corrected values could be swapped). It currently passes 14/17 checks. Two claims still lack the required second, independent verified source and are reported as incomplete rather than silently accepted: reischle2008_g2_80K (only 1 distinct verified primary source(s), need 2); hkust_inp_gaasp_wavelength (only 1 distinct verified primary source(s), need 2); residual_background_80K (only 1 distinct verified primary source(s), need 2). For context, the 80 K claim's only source is Reischle et al., Optics Express 16, 12771 (2008), and the wavelength claim's only source is Gu et al., Optics Express 33, 23732 (2025).</a:t>
             </a:r>
           </a:p>
         </p:txBody>

</xml_diff>

<commit_message>
docs + short deck refreshed for the non-cryogenic rule and the NA-collection correction (codex-luna)
Co-Authored-By: Claude Fable 5.1 <noreply@anthropic.com>
Claude-Session: https://claude.ai/code/session_01BQ7efTVkjp2fGYyjphSZC9
</commit_message>
<xml_diff>
--- a/out/presentation/qd_edge_sps.pptx
+++ b/out/presentation/qd_edge_sps.pptx
@@ -590,7 +590,7 @@
           <a:lstStyle/>
           <a:p>
             <a:r>
-              <a:t>Electrical driving replaces the pump laser used by almost every other single-photon quantum-dot demonstration. fsim_core.transport.hkust_preset() builds the actual p-i-n stack used here: Al0.40Ga0.60As p- and n-claddings around a 148 nm intrinsic region, with the GaAs0.60P0.40 active layer (8 nm) at its centre, following Gu et al.'s (Optics Express 33, 23732, 2025) own electrically pumped device. Forward bias tilts the bands so electrons flow in from the n-side and holes from the p-side and both are captured by the dot in the middle. At the single-dot-scale drive current this design uses (I = 11.3 nA), fsim_core.transport's own I-V solver puts the junction voltage at V_j ≈ 1.50 V at 300 K.</a:t>
+              <a:t>Electrical driving replaces the pump laser used by almost every other single-photon quantum-dot demonstration. fsim_core.transport.hkust_preset() builds the actual p-i-n stack used here: Al0.40Ga0.60As p- and n-claddings around a 148 nm intrinsic region, with the GaAs0.60P0.40 active layer (8 nm) at its centre, following Gu et al.'s (Optics Express 33, 23732, 2025) own electrically pumped device. Forward bias tilts the bands so electrons flow in from the n-side and holes from the p-side and both are captured by the dot in the middle. At the single-dot-scale drive current this design uses (I = 11.3 nA), fsim_core.transport's own I-V solver puts the junction voltage at V_j ≈ 1.61 V at 300 K.</a:t>
             </a:r>
           </a:p>
         </p:txBody>
@@ -800,7 +800,7 @@
           <a:lstStyle/>
           <a:p>
             <a:r>
-              <a:t>g2(0) is the only equation this deck states explicitly, and even it is explained rather than derived: it is the probability of detecting two photons at (almost) the same instant, normalized so that a classical, many-photon source gives 1 and a perfect single-photon emitter gives 0. The dashed curve on this slide is the published 300 K ceiling (no electrically or optically driven III-V dot has ever demonstrated g2(0) &lt; 0.5 at 300 K, docs/rt_edge_contract.md); the solid curve is this design's own best pulsed-drive corner from the acceptance sweep, g2 = 0.3986 -- better than the published ceiling, but only at the extreme corner of the swept range (narrowest linewidth, widest X-XX splitting) and only under pulsed, not continuous, drive.</a:t>
+              <a:t>g2(0) is the only equation this deck states explicitly, and even it is explained rather than derived: it is the probability of detecting two photons at (almost) the same instant, normalized so that a classical, many-photon source gives 1 and a perfect single-photon emitter gives 0. The dashed curve on this slide is the published 300 K ceiling (no electrically or optically driven III-V dot has ever demonstrated g2(0) &lt; 0.5 at 300 K, docs/rt_edge_contract.md); the solid curve is this design's own best pulsed-drive corner from the acceptance sweep, g2 = 0.3214 -- better than the published ceiling, but only at the extreme corner of the swept range (narrowest linewidth, widest X-XX splitting) and only under pulsed, not continuous, drive.</a:t>
             </a:r>
           </a:p>
         </p:txBody>
@@ -870,12 +870,12 @@
           <a:lstStyle/>
           <a:p>
             <a:r>
-              <a:t>VERDICT: FAIL g2_min=0.3986 g2_median_eligible=0.7019 diag_g2_min=0.3986 diag_g2_median_diagnostic=0.7352 flux_max=1544 flux_margin=1.544 flux_shortfall_deprecated=0.6475 median_pass=false coverage_over_eligible=0.25 eligible_fraction=0.1667 eligible=32/192 flux_floor_excluded=160 evidence=incomplete conditional=true headline_coverage=8/192 cw_raw_coverage=0/192 gamma300_pass_max=8 gamma300_threshold=8-10</a:t>
-            </a:r>
-          </a:p>
-          <a:p>
-            <a:r>
-              <a:t>The sweep was generated by scripts/run_rt_edge.py (2026-09-06T10:12:38.980415+00:00) over the full contract-declared grid (docs/rt_edge_contract.md): dot.delta_xx in [4.0, 8.0] meV, dot.gamma300 sampled at the finer values present in sweep.csv, and the detector response (IRF) in [50, 200] ps, evaluated for both the primary (GaAsP-well) and fallback (GaInP-well) design cards. This plot is constructed directly from out/rt_edge/sweep.csv at the largest splitting; the Chatzarakis 2023 and Matsuda 2001 anchors are read from the shared evidence ledger. At the 6.5 meV anchor:  The linewidth is unmeasured for this InP platform. Facet-model note: **Independent check on the combined front-facet factor** (council review round 5, item 6, fixing a tautology): the value above is BACK-SOLVED -- the one factor missing once eta_total, beta, propagation and NA are all already known (eta_total = beta * &lt;combined factor&gt; * eta_prop * eta_NA) -- so a self-check comparing it against that same back-solving would only ever reproduce its own inputs. The genuinely independent check instead recomputes the combined factor FORWARD from this row's own facet transmission (T_facet) and back-facet reflectivity (R_back), trying every candidate formula introspected LIVE from fsim_core/waveguide.py's installed `edge_emission` source right now (never hardcoded, since that file's facet model is being edited concurrently and may change again) -- both as a fused current-model factor and as a legacy front-split-times-T_facet factor, since either grouping may be in effect: forward = 0.935012 via `facet_factor = T / (T + (1 - R_back))` (fused/current-model convention: already includes T_facet), back-solved = 0.935012 -- MATCH (agreement confirms the back-solved value really is the geometric front/back-facet-and-transmission factor waveguide.py computes, not some other quantity folded into eta_total).</a:t>
+              <a:t>VERDICT: FAIL g2_min=0.3214 g2_median_eligible=0.6373 diag_g2_min=0.3214 diag_g2_median_diagnostic=0.6706 flux_max=6890 flux_margin=6.89 flux_shortfall_deprecated=0.1451 median_pass=false coverage_over_eligible=0.3066 eligible_fraction=0.5521 eligible=424/768 flux_floor_excluded=344 evidence=incomplete conditional=true headline_coverage=130/768 cw_raw_coverage=0/424 gamma300_pass_max=10 gamma300_threshold=10-12 T_pass_min=230 headline_by_T=230:60/192,250:34/192,273:24/192,300:12/192</a:t>
+            </a:r>
+          </a:p>
+          <a:p>
+            <a:r>
+              <a:t>The sweep was generated by scripts/run_rt_edge.py (2026-09-06T22:17:31.017160+00:00) over the full contract-declared grid (docs/rt_edge_contract.md): dot.delta_xx in [4.0, 8.0] meV, dot.gamma300 sampled at the finer values present in sweep.csv, and the detector response (IRF) in [50, 200] ps, evaluated for both the primary (GaAsP-well) and fallback (GaInP-well) design cards. This plot is constructed directly from out/rt_edge/sweep.csv at the largest splitting; the Chatzarakis 2023 and Matsuda 2001 anchors are read from the shared evidence ledger. At the 6.5 meV anchor:  The linewidth is unmeasured for this InP platform. Facet-model note: **Independent check on the combined front-facet factor** (council review round 5, item 6, fixing a tautology): the value above is BACK-SOLVED -- the one factor missing once eta_total, beta, propagation and NA are all already known (eta_total = beta * &lt;combined factor&gt; * eta_prop * eta_NA) -- so a self-check comparing it against that same back-solving would only ever reproduce its own inputs. The genuinely independent check instead recomputes the combined factor FORWARD from this row's own facet transmission (T_facet) and back-facet reflectivity (R_back), trying every candidate formula introspected LIVE from fsim_core/waveguide.py's installed `edge_emission` source right now (never hardcoded, since that file's facet model is being edited concurrently and may change again) -- both as a fused current-model factor and as a legacy front-split-times-T_facet factor, since either grouping may be in effect: forward = 0.935012 via `facet_factor = T / (T + (1 - R_back))` (fused/current-model convention: already includes T_facet), back-solved = 0.935012 -- MATCH (agreement confirms the back-solved value really is the geometric front/back-facet-and-transmission factor waveguide.py computes, not some other quantity folded into eta_total).</a:t>
             </a:r>
           </a:p>
         </p:txBody>
@@ -945,7 +945,7 @@
           <a:lstStyle/>
           <a:p>
             <a:r>
-              <a:t>The factor table is read from out/rt_edge/verdict.md: loading=0.632121, t_X=0.5, retention=0.00461745, eta_total=0.0132281, and repetition rate=8e+07 Hz. These levers buy enough collection for only the fallback low-linewidth corner; they do not improve intrinsic g2. The floor, factors, and lever values are the acceptance artifact's brightness decomposition. Facet-model note from the verdict: **Independent check on the combined front-facet factor** (council review round 5, item 6, fixing a tautology): the value above is BACK-SOLVED -- the one factor missing once eta_total, beta, propagation and NA are all already known (eta_total = beta * &lt;combined factor&gt; * eta_prop * eta_NA) -- so a self-check comparing it against that same back-solving would only ever reproduce its own inputs. The genuinely independent check instead recomputes the combined factor FORWARD from this row's own facet transmission (T_facet) and back-facet reflectivity (R_back), trying every candidate formula introspected LIVE from fsim_core/waveguide.py's installed `edge_emission` source right now (never hardcoded, since that file's facet model is being edited concurrently and may change again) -- both as a fused current-model factor and as a legacy front-split-times-T_facet factor, since either grouping may be in effect: forward = 0.935012 via `facet_factor = T / (T + (1 - R_back))` (fused/current-model convention: already includes T_facet), back-solved = 0.935012 -- MATCH (agreement confirms the back-solved value really is the geometric front/back-facet-and-transmission factor waveguide.py computes, not some other quantity folded into eta_total).</a:t>
+              <a:t>The factor table is read from out/rt_edge/verdict.md: loading=0.634719, t_X=0.5, retention=0.0131112, eta_total=0.0206985, and repetition rate=8e+07 Hz. These levers buy enough collection for only the fallback low-linewidth corner; they do not improve intrinsic g2. The floor, factors, and lever values are the acceptance artifact's brightness decomposition. Facet-model note from the verdict: **Independent check on the combined front-facet factor** (council review round 5, item 6, fixing a tautology): the value above is BACK-SOLVED -- the one factor missing once eta_total, beta, propagation and NA are all already known (eta_total = beta * &lt;combined factor&gt; * eta_prop * eta_NA) -- so a self-check comparing it against that same back-solving would only ever reproduce its own inputs. The genuinely independent check instead recomputes the combined factor FORWARD from this row's own facet transmission (T_facet) and back-facet reflectivity (R_back), trying every candidate formula introspected LIVE from fsim_core/waveguide.py's installed `edge_emission` source right now (never hardcoded, since that file's facet model is being edited concurrently and may change again) -- both as a fused current-model factor and as a legacy front-split-times-T_facet factor, since either grouping may be in effect: forward = 0.935012 via `facet_factor = T / (T + (1 - R_back))` (fused/current-model convention: already includes T_facet), back-solved = 0.935012 -- MATCH (agreement confirms the back-solved value really is the geometric front/back-facet-and-transmission factor waveguide.py computes, not some other quantity folded into eta_total).</a:t>
             </a:r>
           </a:p>
         </p:txBody>
@@ -1155,12 +1155,12 @@
           <a:lstStyle/>
           <a:p>
             <a:r>
-              <a:t>VERDICT: FAIL g2_min=0.3986 g2_median_eligible=0.7019 diag_g2_min=0.3986 diag_g2_median_diagnostic=0.7352 flux_max=1544 flux_margin=1.544 flux_shortfall_deprecated=0.6475 median_pass=false coverage_over_eligible=0.25 eligible_fraction=0.1667 eligible=32/192 flux_floor_excluded=160 evidence=incomplete conditional=true headline_coverage=8/192 cw_raw_coverage=0/192 gamma300_pass_max=8 gamma300_threshold=8-10</a:t>
-            </a:r>
-          </a:p>
-          <a:p>
-            <a:r>
-              <a:t>Fail reasons: evidence_incomplete. The stop rule set at the start of this project (g2(0) &lt; 0.5 at 300 K, working electrical injection, in-plane out-coupling, every claim cross-checked against at least two independent papers, and all hallucination tests passing) is not met. The 6.5 meV per-card evaluation passes only for the fallback card; the primary card remains below the flux floor, while evidence claims still lack independent support. This remains a FAIL rather than a conditional PASS because docs/rt_edge_contract.md makes evidence completeness mandatory, and because no published III-V quantum dot -- at any drive scheme -- has demonstrated g2(0) &lt; 0.5 at 300 K under electrical driving.</a:t>
+              <a:t>VERDICT: FAIL g2_min=0.3214 g2_median_eligible=0.6373 diag_g2_min=0.3214 diag_g2_median_diagnostic=0.6706 flux_max=6890 flux_margin=6.89 flux_shortfall_deprecated=0.1451 median_pass=false coverage_over_eligible=0.3066 eligible_fraction=0.5521 eligible=424/768 flux_floor_excluded=344 evidence=incomplete conditional=true headline_coverage=130/768 cw_raw_coverage=0/424 gamma300_pass_max=10 gamma300_threshold=10-12 T_pass_min=230 headline_by_T=230:60/192,250:34/192,273:24/192,300:12/192</a:t>
+            </a:r>
+          </a:p>
+          <a:p>
+            <a:r>
+              <a:t>Fail reasons: evidence_incomplete. The relaxed stop rule requires g2(0) &lt; 0.5 with working electrical injection, in-plane out-coupling, every claim cross-checked against at least two operation at T_hs &gt;= 230 K, with all claims cross-checked against independent papers. The temperature-axis sweep passes at 230 K and above as reported, but evidence claims still lack independent support. This remains a FAIL rather than a conditional PASS because docs/rt_edge_contract.md makes evidence completeness mandatory, and because no published III-V quantum dot -- at any drive scheme -- has demonstrated g2(0) &lt; 0.5 at conditional verdict rather than a PASS.</a:t>
             </a:r>
           </a:p>
         </p:txBody>
@@ -5031,7 +5031,7 @@
               </a:defRPr>
             </a:pPr>
             <a:r>
-              <a:t>• At this design's operating current the junction sits near 1.50 V forward bias</a:t>
+              <a:t>• At this design's operating current the junction sits near 1.61 V forward bias</a:t>
             </a:r>
           </a:p>
         </p:txBody>
@@ -5454,7 +5454,7 @@
               </a:defRPr>
             </a:pPr>
             <a:r>
-              <a:t>• This design's best pulsed corner reaches 0.3986, only at the narrow-line, wide-splitting extreme</a:t>
+              <a:t>• This design's best pulsed corner reaches 0.3214, only at the narrow-line, wide-splitting extreme</a:t>
             </a:r>
           </a:p>
         </p:txBody>
@@ -5580,7 +5580,7 @@
               </a:defRPr>
             </a:pPr>
             <a:r>
-              <a:t>• The threshold is bracketed at gamma300=8-10 meV; 6.5 meV is the per-card anchor</a:t>
+              <a:t>• Non-cryogenic passes begin at T_hs=230 K; pooled gamma300 threshold=10-12 meV</a:t>
             </a:r>
           </a:p>
           <a:p>
@@ -5595,7 +5595,22 @@
               </a:defRPr>
             </a:pPr>
             <a:r>
-              <a:t>• The primary GaAsP card never clears the flux floor; the conditional result is fallback-only</a:t>
+              <a:t>• At 300 K the fallback card passes conditionally; evidence is still incomplete</a:t>
+            </a:r>
+          </a:p>
+          <a:p>
+            <a:pPr>
+              <a:spcAft>
+                <a:spcPts val="1000"/>
+              </a:spcAft>
+              <a:defRPr sz="1800">
+                <a:solidFill>
+                  <a:srgbClr val="1B1F24"/>
+                </a:solidFill>
+              </a:defRPr>
+            </a:pPr>
+            <a:r>
+              <a:t>• The 6.5 meV per-card anchor passes only for the fallback card</a:t>
             </a:r>
           </a:p>
           <a:p>
@@ -5644,7 +5659,7 @@
                 </a:solidFill>
                 <a:latin typeface="Consolas"/>
               </a:rPr>
-              <a:t>VERDICT: FAIL g2_min=0.3986 g2_median_eligible=0.7019 diag_g2_min=0.3986 diag_g2_median_diagnostic=0.7352 flux_max=1544 flux_margin=1.544 flux_shortfall_deprecated=0.6475 median_pass=false coverage_over_eligible=0.25 eligible_fraction=0.1667 eligible=32/192 flux_floor_excluded=160 evidence=incomplete conditional=true headline_coverage=8/192 cw_raw_coverage=0/192 gamma300_pass_max=8 gamma300_threshold=8-10</a:t>
+              <a:t>VERDICT: FAIL g2_min=0.3214 g2_median_eligible=0.6373 diag_g2_min=0.3214 diag_g2_median_diagnostic=0.6706 flux_max=6890 flux_margin=6.89 flux_shortfall_deprecated=0.1451 median_pass=false coverage_over_eligible=0.3066 eligible_fraction=0.5521 eligible=424/768 flux_floor_excluded=344 evidence=incomplete conditional=true headline_coverage=130/768 cw_raw_coverage=0/424 gamma300_pass_max=10 gamma300_threshold=10-12 T_pass_min=230 headline_by_T=230:60/192,250:34/192,273:24/192,300:12/192</a:t>
             </a:r>
           </a:p>
         </p:txBody>
@@ -5755,7 +5770,7 @@
               </a:defRPr>
             </a:pPr>
             <a:r>
-              <a:t>• Flux margin is 1.544; values above 1 clear the 1000 photons/s floor</a:t>
+              <a:t>• Flux margin is 6.89; values above 1 clear the 1000 photons/s floor</a:t>
             </a:r>
           </a:p>
           <a:p>
@@ -5770,7 +5785,7 @@
               </a:defRPr>
             </a:pPr>
             <a:r>
-              <a:t>• The primary GaAsP card never clears the flux floor; only the fallback card supplies the conditional result</a:t>
+              <a:t>• The corrected circular-NA model raises the favourable-corner flux to the reported value</a:t>
             </a:r>
           </a:p>
           <a:p>
@@ -5785,7 +5800,7 @@
               </a:defRPr>
             </a:pPr>
             <a:r>
-              <a:t>• Maximum collected flux is 1544.4 photons/s photons/s</a:t>
+              <a:t>• Maximum collected flux is 6890.03 photons/s photons/s</a:t>
             </a:r>
           </a:p>
         </p:txBody>
@@ -6130,7 +6145,7 @@
               </a:defRPr>
             </a:pPr>
             <a:r>
-              <a:t>• The stop rule is not met as stated: this is a conditional model corner, not a PASS</a:t>
+              <a:t>• Under the relaxed rule, the sweep passes from 230 K; the result remains conditional, not a PASS</a:t>
             </a:r>
           </a:p>
           <a:p>
@@ -6145,7 +6160,7 @@
               </a:defRPr>
             </a:pPr>
             <a:r>
-              <a:t>• PASS needs the measured linewidth to land inside the 8-10 meV threshold bracket</a:t>
+              <a:t>• Pooled gamma300 threshold is 10-12 meV; the 300 K line passes only on the fallback card</a:t>
             </a:r>
           </a:p>
           <a:p>
@@ -6160,7 +6175,7 @@
               </a:defRPr>
             </a:pPr>
             <a:r>
-              <a:t>• The primary card never clears the flux floor; the conditional result rests on fallback alone</a:t>
+              <a:t>• Evidence is incomplete and the primary card has no 300 K headline pass</a:t>
             </a:r>
           </a:p>
           <a:p>
@@ -6209,7 +6224,7 @@
                 </a:solidFill>
                 <a:latin typeface="Consolas"/>
               </a:rPr>
-              <a:t>VERDICT: FAIL g2_min=0.3986 g2_median_eligible=0.7019 diag_g2_min=0.3986 diag_g2_median_diagnostic=0.7352 flux_max=1544 flux_margin=1.544 flux_shortfall_deprecated=0.6475 median_pass=false coverage_over_eligible=0.25 eligible_fraction=0.1667 eligible=32/192 flux_floor_excluded=160 evidence=incomplete conditional=true headline_coverage=8/192 cw_raw_coverage=0/192 gamma300_pass_max=8 gamma300_threshold=8-10</a:t>
+              <a:t>VERDICT: FAIL g2_min=0.3214 g2_median_eligible=0.6373 diag_g2_min=0.3214 diag_g2_median_diagnostic=0.6706 flux_max=6890 flux_margin=6.89 flux_shortfall_deprecated=0.1451 median_pass=false coverage_over_eligible=0.3066 eligible_fraction=0.5521 eligible=424/768 flux_floor_excluded=344 evidence=incomplete conditional=true headline_coverage=130/768 cw_raw_coverage=0/424 gamma300_pass_max=10 gamma300_threshold=10-12 T_pass_min=230 headline_by_T=230:60/192,250:34/192,273:24/192,300:12/192</a:t>
             </a:r>
           </a:p>
         </p:txBody>

</xml_diff>

<commit_message>
peer-review pkg5b: sweep rerun with finite_pulse and tau_cap-density axes; VERDICT FAIL under the corrected model (0/768 eligible); README, tier doc, short deck and deck sections refreshed (coder/Sonnet)
Co-Authored-By: Claude Fable 5.1 <noreply@anthropic.com>
Claude-Session: https://claude.ai/code/session_01BQ7efTVkjp2fGYyjphSZC9
</commit_message>
<xml_diff>
--- a/out/presentation/qd_edge_sps.pptx
+++ b/out/presentation/qd_edge_sps.pptx
@@ -590,7 +590,7 @@
           <a:lstStyle/>
           <a:p>
             <a:r>
-              <a:t>Electrical driving replaces the pump laser used by almost every other single-photon quantum-dot demonstration. fsim_core.transport.hkust_preset() builds the actual p-i-n stack used here: Al0.40Ga0.60As p- and n-claddings around a 148 nm intrinsic region, with the GaAs0.60P0.40 active layer (8 nm) at its centre, following Gu et al.'s (Optics Express 33, 23732, 2025) own electrically pumped device. Forward bias tilts the bands so electrons flow in from the n-side and holes from the p-side and both are captured by the dot in the middle. At the single-dot-scale drive current this design uses (I = 11.3 nA), fsim_core.transport's own I-V solver puts the junction voltage at V_j ≈ 1.61 V at 300 K.</a:t>
+              <a:t>Electrical driving replaces the pump laser used by almost every other single-photon quantum-dot demonstration. fsim_core.transport.hkust_preset() builds the actual p-i-n stack used here: Al0.40Ga0.60As p- and n-claddings around a 148 nm intrinsic region, with the GaAs0.60P0.40 active layer (8 nm) at its centre, following Gu et al.'s (Optics Express 33, 23732, 2025) own electrically pumped device. Forward bias tilts the bands so electrons flow in from the n-side and holes from the p-side and both are captured by the dot in the middle. At the single-dot-scale drive current this design uses (I = 5.2 nA), fsim_core.transport's own I-V solver puts the junction voltage at V_j ≈ 1.58 V at 300 K.</a:t>
             </a:r>
           </a:p>
         </p:txBody>
@@ -730,7 +730,7 @@
           <a:lstStyle/>
           <a:p>
             <a:r>
-              <a:t>fsim_core.waveguide.py solves the actual guided optical mode of the ridge stack (an (Al,Ga)InP core around the GaAsP well, on a GaAs substrate) with a scalar effective-index model (Lecamp, Lalanne &amp; Hugonin, Phys. Rev. Lett. 99, 023902 (2007)). For this design's stack at 668 nm the solved mode has n_eff = 3.18 and a beta factor (fraction of the dot's spontaneous emission that couples into the guided mode) of 2.87%, sweeping to 2.9% across the acceptance-sweep grid; an uncoated facet then transmits 73% of the guided light out of the chip (Fresnel reflection at the semiconductor-air interface). Per Lemma 1 of docs/rt_edge_contract.md, none of this changes the intrinsic multiphoton probability -- it only sets how much of the light that is emitted is actually collected.</a:t>
+              <a:t>fsim_core.waveguide.py solves the actual guided optical mode of the ridge stack (an (Al,Ga)InP core around the GaAsP well, on a GaAs substrate) with a scalar effective-index model (Lecamp, Lalanne &amp; Hugonin, Phys. Rev. Lett. 99, 023902 (2007)). For this design's stack at 668 nm the solved mode has n_eff = 3.18 and a beta factor (fraction of the dot's spontaneous emission that couples into the guided mode) of 2.87%, sweeping to 3.0% across the acceptance-sweep grid; an uncoated facet then transmits 73% of the guided light out of the chip (Fresnel reflection at the semiconductor-air interface). Per Lemma 1 of docs/rt_edge_contract.md, none of this changes the intrinsic multiphoton probability -- it only sets how much of the light that is emitted is actually collected.</a:t>
             </a:r>
           </a:p>
         </p:txBody>
@@ -800,7 +800,7 @@
           <a:lstStyle/>
           <a:p>
             <a:r>
-              <a:t>g2(0) is the only equation this deck states explicitly, and even it is explained rather than derived: it is the probability of detecting two photons at (almost) the same instant, normalized so that a classical, many-photon source gives 1 and a perfect single-photon emitter gives 0. The dashed curve on this slide is the published 300 K ceiling (no electrically or optically driven III-V dot has ever demonstrated g2(0) &lt; 0.5 at 300 K, docs/rt_edge_contract.md); the solid curve is this design's own best pulsed-drive corner from the acceptance sweep, g2 = 0.3214 -- better than the published ceiling, but only at the extreme corner of the swept range (narrowest linewidth, widest X-XX splitting) and only under pulsed, not continuous, drive.</a:t>
+              <a:t>g2(0) is the only equation this deck states explicitly, and even it is explained rather than derived: it is the probability of detecting two photons at (almost) the same instant, normalized so that a classical, many-photon source gives 1 and a perfect single-photon emitter gives 0. The dashed curve on this slide is the published 300 K ceiling (no electrically or optically driven III-V dot has ever demonstrated g2(0) &lt; 0.5 at 300 K, docs/rt_edge_contract.md); the solid curve is this design's own best pulsed-drive corner from the acceptance sweep, g2 = 0.9817 -- WORSE than the published ceiling under the corrected finite-pulse loading model (peer-review-triage.md finding 1), and this corner does not clear the collected-flux eligibility floor either, so it is a diagnostic value, not a measurable one.</a:t>
             </a:r>
           </a:p>
         </p:txBody>
@@ -870,12 +870,12 @@
           <a:lstStyle/>
           <a:p>
             <a:r>
-              <a:t>VERDICT: FAIL g2_min=0.3214 g2_median_eligible=0.6373 diag_g2_min=0.3214 diag_g2_median_diagnostic=0.6706 flux_max=6890 flux_margin=6.89 flux_shortfall_deprecated=0.1451 median_pass=false coverage_over_eligible=0.3066 eligible_fraction=0.5521 eligible=424/768 flux_floor_excluded=344 evidence=incomplete conditional=true headline_coverage=130/768 cw_raw_coverage=0/424 gamma300_pass_max=10 gamma300_threshold=10-12 T_pass_min=230 headline_by_T=230:60/192,250:34/192,273:24/192,300:12/192</a:t>
-            </a:r>
-          </a:p>
-          <a:p>
-            <a:r>
-              <a:t>The sweep was generated by scripts/run_rt_edge.py (2026-09-06T22:17:31.017160+00:00) over the full contract-declared grid (docs/rt_edge_contract.md): dot.delta_xx in [4.0, 8.0] meV, dot.gamma300 sampled at the finer values present in sweep.csv, and the detector response (IRF) in [50, 200] ps, evaluated for both the primary (GaAsP-well) and fallback (GaInP-well) design cards. This plot is constructed directly from out/rt_edge/sweep.csv at the largest splitting; the Chatzarakis 2023 and Matsuda 2001 anchors are read from the shared evidence ledger. At the 6.5 meV anchor:  The linewidth is unmeasured for this InP platform. Facet-model note: **Independent check on the combined front-facet factor** (council review round 5, item 6, fixing a tautology): the value above is BACK-SOLVED -- the one factor missing once eta_total, beta, propagation and NA are all already known (eta_total = beta * &lt;combined factor&gt; * eta_prop * eta_NA) -- so a self-check comparing it against that same back-solving would only ever reproduce its own inputs. The genuinely independent check instead recomputes the combined factor FORWARD from this row's own facet transmission (T_facet) and back-facet reflectivity (R_back), trying every candidate formula introspected LIVE from fsim_core/waveguide.py's installed `edge_emission` source right now (never hardcoded, since that file's facet model is being edited concurrently and may change again) -- both as a fused current-model factor and as a legacy front-split-times-T_facet factor, since either grouping may be in effect: forward = 0.935012 via `facet_factor = T / (T + (1 - R_back))` (fused/current-model convention: already includes T_facet), back-solved = 0.935012 -- MATCH (agreement confirms the back-solved value really is the geometric front/back-facet-and-transmission factor waveguide.py computes, not some other quantity folded into eta_total).</a:t>
+              <a:t>VERDICT: FAIL model=finite_pulse:true,tau_cap_density:false g2_min=nan g2_median_eligible=nan diag_g2_min=0.9817 diag_g2_median_diagnostic=0.9993 flux_max=582.8 flux_margin=0.5828 flux_shortfall_deprecated=1.716 median_pass=false coverage_over_eligible=nan eligible_fraction=0 eligible=0/768 flux_floor_excluded=768 evidence=incomplete conditional=false headline_coverage=0/768 headline_coverage_pulsed=0/384 headline_dedup_mismatch_groups=0 eligible_dedup=0/384 eligible_dedup_mismatch_groups=0 rows_scheduled=0/768 cw_raw_coverage=0/0 gamma300_pass_max=nan gamma300_threshold=n/a T_pass_min=none headline_by_T=230:0/192,250:0/192,273:0/192,300:0/192 headline_by_T_pulsed=230:0/96,250:0/96,273:0/96,300:0/96</a:t>
+            </a:r>
+          </a:p>
+          <a:p>
+            <a:r>
+              <a:t>The sweep was generated by scripts/run_rt_edge.py (2026-09-08T02:10:45.950278+00:00) over the full contract-declared grid (docs/rt_edge_contract.md): dot.delta_xx in [4.0, 8.0] meV, dot.gamma300 sampled at the finer values present in sweep.csv, and the detector response (IRF) in [50, 200] ps, evaluated for both the primary (GaAsP-well) and fallback (GaInP-well) design cards. This plot is constructed directly from out/rt_edge/sweep.csv at the largest splitting; the Chatzarakis 2023 and Matsuda 2001 anchors are read from the shared evidence ledger. At the 6.5 meV anchor:  The linewidth is unmeasured for this InP platform. Facet-model note: </a:t>
             </a:r>
           </a:p>
         </p:txBody>
@@ -945,7 +945,7 @@
           <a:lstStyle/>
           <a:p>
             <a:r>
-              <a:t>The factor table is read from out/rt_edge/verdict.md: loading=0.634719, t_X=0.5, retention=0.0131112, eta_total=0.0206985, and repetition rate=8e+07 Hz. These levers buy enough collection for only the fallback low-linewidth corner; they do not improve intrinsic g2. The floor, factors, and lever values are the acceptance artifact's brightness decomposition. Facet-model note from the verdict: **Independent check on the combined front-facet factor** (council review round 5, item 6, fixing a tautology): the value above is BACK-SOLVED -- the one factor missing once eta_total, beta, propagation and NA are all already known (eta_total = beta * &lt;combined factor&gt; * eta_prop * eta_NA) -- so a self-check comparing it against that same back-solving would only ever reproduce its own inputs. The genuinely independent check instead recomputes the combined factor FORWARD from this row's own facet transmission (T_facet) and back-facet reflectivity (R_back), trying every candidate formula introspected LIVE from fsim_core/waveguide.py's installed `edge_emission` source right now (never hardcoded, since that file's facet model is being edited concurrently and may change again) -- both as a fused current-model factor and as a legacy front-split-times-T_facet factor, since either grouping may be in effect: forward = 0.935012 via `facet_factor = T / (T + (1 - R_back))` (fused/current-model convention: already includes T_facet), back-solved = 0.935012 -- MATCH (agreement confirms the back-solved value really is the geometric front/back-facet-and-transmission factor waveguide.py computes, not some other quantity folded into eta_total).</a:t>
+              <a:t>The factor table is read from out/rt_edge/verdict.md: loading=0.419876, t_X=0.5, retention=0.00134802, and repetition rate=8e+07 Hz. These levers no longer buy enough collection at any sampled corner under the corrected finite-pulse loading model; they do not improve intrinsic g2 either way. The floor, factors, and lever values are the acceptance artifact's brightness decomposition. Facet-model note from the verdict: </a:t>
             </a:r>
           </a:p>
         </p:txBody>
@@ -1155,12 +1155,12 @@
           <a:lstStyle/>
           <a:p>
             <a:r>
-              <a:t>VERDICT: FAIL g2_min=0.3214 g2_median_eligible=0.6373 diag_g2_min=0.3214 diag_g2_median_diagnostic=0.6706 flux_max=6890 flux_margin=6.89 flux_shortfall_deprecated=0.1451 median_pass=false coverage_over_eligible=0.3066 eligible_fraction=0.5521 eligible=424/768 flux_floor_excluded=344 evidence=incomplete conditional=true headline_coverage=130/768 cw_raw_coverage=0/424 gamma300_pass_max=10 gamma300_threshold=10-12 T_pass_min=230 headline_by_T=230:60/192,250:34/192,273:24/192,300:12/192</a:t>
-            </a:r>
-          </a:p>
-          <a:p>
-            <a:r>
-              <a:t>Fail reasons: evidence_incomplete. The relaxed stop rule requires g2(0) &lt; 0.5 with working electrical injection, in-plane out-coupling, every claim cross-checked against at least two operation at T_hs &gt;= 230 K, with all claims cross-checked against independent papers. The temperature-axis sweep passes at 230 K and above as reported, but evidence claims still lack independent support. This remains a FAIL rather than a conditional PASS because docs/rt_edge_contract.md makes evidence completeness mandatory, and because no published III-V quantum dot -- at any drive scheme -- has demonstrated g2(0) &lt; 0.5 at conditional verdict rather than a PASS.</a:t>
+              <a:t>VERDICT: FAIL model=finite_pulse:true,tau_cap_density:false g2_min=nan g2_median_eligible=nan diag_g2_min=0.9817 diag_g2_median_diagnostic=0.9993 flux_max=582.8 flux_margin=0.5828 flux_shortfall_deprecated=1.716 median_pass=false coverage_over_eligible=nan eligible_fraction=0 eligible=0/768 flux_floor_excluded=768 evidence=incomplete conditional=false headline_coverage=0/768 headline_coverage_pulsed=0/384 headline_dedup_mismatch_groups=0 eligible_dedup=0/384 eligible_dedup_mismatch_groups=0 rows_scheduled=0/768 cw_raw_coverage=0/0 gamma300_pass_max=nan gamma300_threshold=n/a T_pass_min=none headline_by_T=230:0/192,250:0/192,273:0/192,300:0/192 headline_by_T_pulsed=230:0/96,250:0/96,273:0/96,300:0/96</a:t>
+            </a:r>
+          </a:p>
+          <a:p>
+            <a:r>
+              <a:t>Fail reasons: evidence_incomplete, no_eligible_rows. The relaxed stop rule requires g2(0) &lt; 0.5 with working electrical injection, in-plane out-coupling, and every claim cross-checked against at least two independent papers, at T_hs &gt;= 230 K. Under the corrected finite-pulse loading calculation (peer-review-triage.md finding 1), replacing the legacy static per-pulse loading approximation every earlier package used, no sampled corner anywhere in the grid clears even the collected-flux eligibility floor, let alone the g2(0) gate. This is not a conditional PASS pending evidence completion: the verdict now fails BOTH on evidence (docs/rt_edge_contract.md requires completeness) AND on having no eligible row at all -- closing the evidence gaps alone would not flip this sweep to PASS.</a:t>
             </a:r>
           </a:p>
         </p:txBody>
@@ -5031,7 +5031,7 @@
               </a:defRPr>
             </a:pPr>
             <a:r>
-              <a:t>• At this design's operating current the junction sits near 1.61 V forward bias</a:t>
+              <a:t>• At this design's operating current the junction sits near 1.58 V forward bias</a:t>
             </a:r>
           </a:p>
         </p:txBody>
@@ -5298,7 +5298,7 @@
               </a:defRPr>
             </a:pPr>
             <a:r>
-              <a:t>• This design's mode captures about 2.9-2.9% of the dot's light (beta)</a:t>
+              <a:t>• This design's mode captures about 2.9-3.0% of the dot's light (beta)</a:t>
             </a:r>
           </a:p>
           <a:p>
@@ -5454,7 +5454,7 @@
               </a:defRPr>
             </a:pPr>
             <a:r>
-              <a:t>• This design's best pulsed corner reaches 0.3214, only at the narrow-line, wide-splitting extreme</a:t>
+              <a:t>• Under the corrected finite-pulse loading model, the best DIAGNOSTIC corner reaches 0.9817 -- above threshold and below the flux floor</a:t>
             </a:r>
           </a:p>
         </p:txBody>
@@ -5580,7 +5580,7 @@
               </a:defRPr>
             </a:pPr>
             <a:r>
-              <a:t>• Non-cryogenic passes begin at T_hs=230 K; pooled gamma300 threshold=10-12 meV</a:t>
+              <a:t>• Under the corrected finite-pulse loading model, no sampled corner clears the flux floor (gamma300 threshold=n/a)</a:t>
             </a:r>
           </a:p>
           <a:p>
@@ -5595,7 +5595,7 @@
               </a:defRPr>
             </a:pPr>
             <a:r>
-              <a:t>• At 300 K the fallback card passes conditionally; evidence is still incomplete</a:t>
+              <a:t>• No T_hs, card, or lever combination passes the headline gate; evidence is also still incomplete</a:t>
             </a:r>
           </a:p>
           <a:p>
@@ -5610,7 +5610,7 @@
               </a:defRPr>
             </a:pPr>
             <a:r>
-              <a:t>• The 6.5 meV per-card anchor passes only for the fallback card</a:t>
+              <a:t>• The 6.5 meV per-card anchor now fails on both cards under the corrected model</a:t>
             </a:r>
           </a:p>
           <a:p>
@@ -5659,7 +5659,7 @@
                 </a:solidFill>
                 <a:latin typeface="Consolas"/>
               </a:rPr>
-              <a:t>VERDICT: FAIL g2_min=0.3214 g2_median_eligible=0.6373 diag_g2_min=0.3214 diag_g2_median_diagnostic=0.6706 flux_max=6890 flux_margin=6.89 flux_shortfall_deprecated=0.1451 median_pass=false coverage_over_eligible=0.3066 eligible_fraction=0.5521 eligible=424/768 flux_floor_excluded=344 evidence=incomplete conditional=true headline_coverage=130/768 cw_raw_coverage=0/424 gamma300_pass_max=10 gamma300_threshold=10-12 T_pass_min=230 headline_by_T=230:60/192,250:34/192,273:24/192,300:12/192</a:t>
+              <a:t>VERDICT: FAIL model=finite_pulse:true,tau_cap_density:false g2_min=nan g2_median_eligible=nan diag_g2_min=0.9817 diag_g2_median_diagnostic=0.9993 flux_max=582.8 flux_margin=0.5828 flux_shortfall_deprecated=1.716 median_pass=false coverage_over_eligible=nan eligible_fraction=0 eligible=0/768 flux_floor_excluded=768 evidence=incomplete conditional=false headline_coverage=0/768 headline_coverage_pulsed=0/384 headline_dedup_mismatch_groups=0 eligible_dedup=0/384 eligible_dedup_mismatch_groups=0 rows_scheduled=0/768 cw_raw_coverage=0/0 gamma300_pass_max=nan gamma300_threshold=n/a T_pass_min=none headline_by_T=230:0/192,250:0/192,273:0/192,300:0/192 headline_by_T_pulsed=230:0/96,250:0/96,273:0/96,300:0/96</a:t>
             </a:r>
           </a:p>
         </p:txBody>
@@ -5770,7 +5770,7 @@
               </a:defRPr>
             </a:pPr>
             <a:r>
-              <a:t>• Flux margin is 6.89; values above 1 clear the 1000 photons/s floor</a:t>
+              <a:t>• Flux margin is 0.5828; values above 1 clear the 1000 photons/s floor, below 1 do not</a:t>
             </a:r>
           </a:p>
           <a:p>
@@ -5785,7 +5785,7 @@
               </a:defRPr>
             </a:pPr>
             <a:r>
-              <a:t>• The corrected circular-NA model raises the favourable-corner flux to the reported value</a:t>
+              <a:t>• The corrected circular-NA model raises collected flux, but not enough under the corrected loading model</a:t>
             </a:r>
           </a:p>
           <a:p>
@@ -5800,7 +5800,7 @@
               </a:defRPr>
             </a:pPr>
             <a:r>
-              <a:t>• Maximum collected flux is 6890.03 photons/s photons/s</a:t>
+              <a:t>• Maximum collected flux is 578.843 photons/s photons/s</a:t>
             </a:r>
           </a:p>
         </p:txBody>
@@ -6145,7 +6145,7 @@
               </a:defRPr>
             </a:pPr>
             <a:r>
-              <a:t>• Under the relaxed rule, the sweep passes from 230 K; the result remains conditional, not a PASS</a:t>
+              <a:t>• Under the corrected finite-pulse loading model, NO sampled corner passes at any T_hs</a:t>
             </a:r>
           </a:p>
           <a:p>
@@ -6160,7 +6160,7 @@
               </a:defRPr>
             </a:pPr>
             <a:r>
-              <a:t>• Pooled gamma300 threshold is 10-12 meV; the 300 K line passes only on the fallback card</a:t>
+              <a:t>• Pooled gamma300 threshold is n/a; neither card's own 6.5 meV anchor passes either</a:t>
             </a:r>
           </a:p>
           <a:p>
@@ -6175,7 +6175,7 @@
               </a:defRPr>
             </a:pPr>
             <a:r>
-              <a:t>• Evidence is incomplete and the primary card has no 300 K headline pass</a:t>
+              <a:t>• Evidence is also still incomplete: this is a double FAIL, not a conditional PASS</a:t>
             </a:r>
           </a:p>
           <a:p>
@@ -6224,7 +6224,7 @@
                 </a:solidFill>
                 <a:latin typeface="Consolas"/>
               </a:rPr>
-              <a:t>VERDICT: FAIL g2_min=0.3214 g2_median_eligible=0.6373 diag_g2_min=0.3214 diag_g2_median_diagnostic=0.6706 flux_max=6890 flux_margin=6.89 flux_shortfall_deprecated=0.1451 median_pass=false coverage_over_eligible=0.3066 eligible_fraction=0.5521 eligible=424/768 flux_floor_excluded=344 evidence=incomplete conditional=true headline_coverage=130/768 cw_raw_coverage=0/424 gamma300_pass_max=10 gamma300_threshold=10-12 T_pass_min=230 headline_by_T=230:60/192,250:34/192,273:24/192,300:12/192</a:t>
+              <a:t>VERDICT: FAIL model=finite_pulse:true,tau_cap_density:false g2_min=nan g2_median_eligible=nan diag_g2_min=0.9817 diag_g2_median_diagnostic=0.9993 flux_max=582.8 flux_margin=0.5828 flux_shortfall_deprecated=1.716 median_pass=false coverage_over_eligible=nan eligible_fraction=0 eligible=0/768 flux_floor_excluded=768 evidence=incomplete conditional=false headline_coverage=0/768 headline_coverage_pulsed=0/384 headline_dedup_mismatch_groups=0 eligible_dedup=0/384 eligible_dedup_mismatch_groups=0 rows_scheduled=0/768 cw_raw_coverage=0/0 gamma300_pass_max=nan gamma300_threshold=n/a T_pass_min=none headline_by_T=230:0/192,250:0/192,273:0/192,300:0/192 headline_by_T_pulsed=230:0/96,250:0/96,273:0/96,300:0/96</a:t>
             </a:r>
           </a:p>
         </p:txBody>

</xml_diff>

<commit_message>
peer-review pkg5b fix: model-aware brightness self-check, section 3 on the headline finite-pulse model with repo_numbers, tier/README sensitivity rows and mechanism, live lever figure and NA ratio, short deck wording (coder/Sonnet)
Co-Authored-By: Claude Fable 5.1 <noreply@anthropic.com>
Claude-Session: https://claude.ai/code/session_01BQ7efTVkjp2fGYyjphSZC9
</commit_message>
<xml_diff>
--- a/out/presentation/qd_edge_sps.pptx
+++ b/out/presentation/qd_edge_sps.pptx
@@ -875,7 +875,7 @@
           </a:p>
           <a:p>
             <a:r>
-              <a:t>The sweep was generated by scripts/run_rt_edge.py (2026-09-08T02:10:45.950278+00:00) over the full contract-declared grid (docs/rt_edge_contract.md): dot.delta_xx in [4.0, 8.0] meV, dot.gamma300 sampled at the finer values present in sweep.csv, and the detector response (IRF) in [50, 200] ps, evaluated for both the primary (GaAsP-well) and fallback (GaInP-well) design cards. This plot is constructed directly from out/rt_edge/sweep.csv at the largest splitting; the Chatzarakis 2023 and Matsuda 2001 anchors are read from the shared evidence ledger. At the 6.5 meV anchor:  The linewidth is unmeasured for this InP platform. Facet-model note: </a:t>
+              <a:t>The sweep was generated by scripts/run_rt_edge.py (2026-09-08T04:03:18.524447+00:00) over the full contract-declared grid (docs/rt_edge_contract.md): dot.delta_xx in [4.0, 8.0] meV, dot.gamma300 sampled at the finer values present in sweep.csv, and the detector response (IRF) in [50, 200] ps, evaluated for both the primary (GaAsP-well) and fallback (GaInP-well) design cards. This plot is constructed directly from out/rt_edge/sweep.csv at the largest splitting; the Chatzarakis 2023 and Matsuda 2001 anchors are read from the shared evidence ledger. At the 6.5 meV anchor:  The linewidth is unmeasured for this InP platform. Facet-model note: </a:t>
             </a:r>
           </a:p>
         </p:txBody>
@@ -5800,7 +5800,7 @@
               </a:defRPr>
             </a:pPr>
             <a:r>
-              <a:t>• Maximum collected flux is 578.843 photons/s photons/s</a:t>
+              <a:t>• Maximum collected flux across the grid is 582.8 photons/s; the best-diagnostic (lowest-g2) row reaches 578.843 photons/s</a:t>
             </a:r>
           </a:p>
         </p:txBody>

</xml_diff>

<commit_message>
peer-review pkg5b fix2: independent finite-pulse flux self-check (falsifiable), mechanism sentence corrected (pump pulse, not a counting gate), section 3 tables labelled by drive model, single lever chain on 04-11, short-deck notes (coder/Sonnet)
Co-Authored-By: Claude Fable 5.1 <noreply@anthropic.com>
Claude-Session: https://claude.ai/code/session_01BQ7efTVkjp2fGYyjphSZC9
</commit_message>
<xml_diff>
--- a/out/presentation/qd_edge_sps.pptx
+++ b/out/presentation/qd_edge_sps.pptx
@@ -875,7 +875,7 @@
           </a:p>
           <a:p>
             <a:r>
-              <a:t>The sweep was generated by scripts/run_rt_edge.py (2026-09-08T04:03:18.524447+00:00) over the full contract-declared grid (docs/rt_edge_contract.md): dot.delta_xx in [4.0, 8.0] meV, dot.gamma300 sampled at the finer values present in sweep.csv, and the detector response (IRF) in [50, 200] ps, evaluated for both the primary (GaAsP-well) and fallback (GaInP-well) design cards. This plot is constructed directly from out/rt_edge/sweep.csv at the largest splitting; the Chatzarakis 2023 and Matsuda 2001 anchors are read from the shared evidence ledger. At the 6.5 meV anchor:  The linewidth is unmeasured for this InP platform. Facet-model note: </a:t>
+              <a:t>The sweep was generated by scripts/run_rt_edge.py (2026-09-08T04:28:53.164218+00:00) over the full contract-declared grid (docs/rt_edge_contract.md): dot.delta_xx in [4.0, 8.0] meV, dot.gamma300 sampled at the finer values present in sweep.csv, and the detector response (IRF) in [50, 200] ps, evaluated for both the primary (GaAsP-well) and fallback (GaInP-well) design cards. This plot is constructed directly from out/rt_edge/sweep.csv at the largest splitting; the Chatzarakis 2023 and Matsuda 2001 anchors are read from the shared evidence ledger. At the 6.5 meV anchor:  The linewidth is unmeasured for this InP platform. Facet-model note: </a:t>
             </a:r>
           </a:p>
         </p:txBody>
@@ -945,7 +945,7 @@
           <a:lstStyle/>
           <a:p>
             <a:r>
-              <a:t>The factor table is read from out/rt_edge/verdict.md: loading=0.419876, t_X=0.5, retention=0.00134802, and repetition rate=8e+07 Hz. These levers no longer buy enough collection at any sampled corner under the corrected finite-pulse loading model; they do not improve intrinsic g2 either way. The floor, factors, and lever values are the acceptance artifact's brightness decomposition. Facet-model note from the verdict: </a:t>
+              <a:t>The factor table is read from out/rt_edge/verdict.md's finite-pulse chain (pkg5b-fix2 item 5: the headline model's own formula, not the superseded static loading/t_X/S product): finite_pulse_mean_counts=0.000364481, eta_total=0.0198516, and repetition rate=8e+07 Hz -- mean_counts x eta_total x rep_rate reproduces the reported collected flux; loading=0.419876, t_X=0.5 and retention=0.00134802 are shown in the verdict for reference only and are NOT part of this row's finite-pulse flux formula (already folded into finite_pulse_mean_counts). These levers no longer buy enough collection at any sampled corner under the corrected finite-pulse loading model; they do not improve intrinsic g2 either way. The floor, factors, and lever values are the acceptance artifact's brightness decomposition. Facet-model note from the verdict: </a:t>
             </a:r>
           </a:p>
         </p:txBody>

</xml_diff>